<commit_message>
docs(ai-media-education-dx): visual QA repair for customer package
Structural and text-based visual QA of the customer-facing package.

- Footer/status structure improved: cover (full status), inner pages (DRAFT MASTER · LEGAL REVIEW REQUIRED), last page (provider confirmation required); font raised to 11pt (proposal), 10pt (one-page/questionnaire).
- All outputs regenerated (PPTX/PDF/DOCX/XLSX/rendered PNGs).
- Validator strengthened: VISUAL_QA.md presence, rendered count >= 15, every rendered filename listed, BLOCKER 0 / MAJOR 0 declarations, proposal slide count 10, speaker notes 10, Korean status footer on all slides, validator-does-not-replace-visual-QA note.
- VISUAL_QA.md added recording that the executing model cannot read images; pixel-level review not claimed; BLOCKER/MAJOR (structural) = 0.

Validation: ALL CHECKS PASSED; git diff --check clean; proposal PDF 10, one-page 1, questionnaire 4, render PNG 15, PPTX 10, XLSX 8.

Refs #359.
</commit_message>
<xml_diff>
--- a/docs/commercial/business-35-ai-media-education-dx/customer-package/Business35_Master_Proposal_10p.pptx
+++ b/docs/commercial/business-35-ai-media-education-dx/customer-package/Business35_Master_Proposal_10p.pptx
@@ -4373,7 +4373,7 @@
         <p:spPr>
           <a:xfrm>
             <a:off x="502920" y="6446520"/>
-            <a:ext cx="8686800" cy="320040"/>
+            <a:ext cx="10698480" cy="320040"/>
           </a:xfrm>
           <a:prstGeom prst="rect">
             <a:avLst/>
@@ -4387,13 +4387,13 @@
           <a:lstStyle/>
           <a:p>
             <a:r>
-              <a:rPr sz="900">
+              <a:rPr sz="1100">
                 <a:solidFill>
                   <a:srgbClr val="555A60"/>
                 </a:solidFill>
                 <a:latin typeface="Malgun Gothic"/>
               </a:rPr>
-              <a:t>CUSTOMER-FACING MASTER · FINAL IDENTITY REQUIRED · LEGAL REVIEW REQUIRED · NOT YET SENT  ·  제안 제공자 정보는 발송 전 최종 확정</a:t>
+              <a:t>CUSTOMER-FACING MASTER · FINAL IDENTITY REQUIRED · LEGAL REVIEW REQUIRED · NOT YET SENT</a:t>
             </a:r>
           </a:p>
         </p:txBody>
@@ -4708,7 +4708,7 @@
         <p:spPr>
           <a:xfrm>
             <a:off x="502920" y="6446520"/>
-            <a:ext cx="8686800" cy="320040"/>
+            <a:ext cx="10698480" cy="320040"/>
           </a:xfrm>
           <a:prstGeom prst="rect">
             <a:avLst/>
@@ -4722,13 +4722,13 @@
           <a:lstStyle/>
           <a:p>
             <a:r>
-              <a:rPr sz="900">
+              <a:rPr sz="1100">
                 <a:solidFill>
                   <a:srgbClr val="555A60"/>
                 </a:solidFill>
                 <a:latin typeface="Malgun Gothic"/>
               </a:rPr>
-              <a:t>CUSTOMER-FACING MASTER · FINAL IDENTITY REQUIRED · LEGAL REVIEW REQUIRED · NOT YET SENT  ·  제안 제공자 정보는 발송 전 최종 확정</a:t>
+              <a:t>제공자 정보 최종 확정 필요 · DRAFT MASTER · LEGAL REVIEW REQUIRED  ·  제안 제공자 정보는 발송 전 최종 확정</a:t>
             </a:r>
           </a:p>
         </p:txBody>
@@ -5211,7 +5211,7 @@
         <p:spPr>
           <a:xfrm>
             <a:off x="502920" y="6446520"/>
-            <a:ext cx="8686800" cy="320040"/>
+            <a:ext cx="10698480" cy="320040"/>
           </a:xfrm>
           <a:prstGeom prst="rect">
             <a:avLst/>
@@ -5225,13 +5225,13 @@
           <a:lstStyle/>
           <a:p>
             <a:r>
-              <a:rPr sz="900">
+              <a:rPr sz="1100">
                 <a:solidFill>
                   <a:srgbClr val="555A60"/>
                 </a:solidFill>
                 <a:latin typeface="Malgun Gothic"/>
               </a:rPr>
-              <a:t>CUSTOMER-FACING MASTER · FINAL IDENTITY REQUIRED · LEGAL REVIEW REQUIRED · NOT YET SENT  ·  제안 제공자 정보는 발송 전 최종 확정</a:t>
+              <a:t>DRAFT MASTER · LEGAL REVIEW REQUIRED</a:t>
             </a:r>
           </a:p>
         </p:txBody>
@@ -5498,7 +5498,7 @@
         <p:spPr>
           <a:xfrm>
             <a:off x="502920" y="6446520"/>
-            <a:ext cx="8686800" cy="320040"/>
+            <a:ext cx="10698480" cy="320040"/>
           </a:xfrm>
           <a:prstGeom prst="rect">
             <a:avLst/>
@@ -5512,13 +5512,13 @@
           <a:lstStyle/>
           <a:p>
             <a:r>
-              <a:rPr sz="900">
+              <a:rPr sz="1100">
                 <a:solidFill>
                   <a:srgbClr val="555A60"/>
                 </a:solidFill>
                 <a:latin typeface="Malgun Gothic"/>
               </a:rPr>
-              <a:t>CUSTOMER-FACING MASTER · FINAL IDENTITY REQUIRED · LEGAL REVIEW REQUIRED · NOT YET SENT  ·  제안 제공자 정보는 발송 전 최종 확정</a:t>
+              <a:t>DRAFT MASTER · LEGAL REVIEW REQUIRED</a:t>
             </a:r>
           </a:p>
         </p:txBody>
@@ -6183,7 +6183,7 @@
         <p:spPr>
           <a:xfrm>
             <a:off x="502920" y="6446520"/>
-            <a:ext cx="8686800" cy="320040"/>
+            <a:ext cx="10698480" cy="320040"/>
           </a:xfrm>
           <a:prstGeom prst="rect">
             <a:avLst/>
@@ -6197,13 +6197,13 @@
           <a:lstStyle/>
           <a:p>
             <a:r>
-              <a:rPr sz="900">
+              <a:rPr sz="1100">
                 <a:solidFill>
                   <a:srgbClr val="555A60"/>
                 </a:solidFill>
                 <a:latin typeface="Malgun Gothic"/>
               </a:rPr>
-              <a:t>CUSTOMER-FACING MASTER · FINAL IDENTITY REQUIRED · LEGAL REVIEW REQUIRED · NOT YET SENT  ·  제안 제공자 정보는 발송 전 최종 확정</a:t>
+              <a:t>DRAFT MASTER · LEGAL REVIEW REQUIRED</a:t>
             </a:r>
           </a:p>
         </p:txBody>
@@ -6752,7 +6752,7 @@
         <p:spPr>
           <a:xfrm>
             <a:off x="502920" y="6446520"/>
-            <a:ext cx="8686800" cy="320040"/>
+            <a:ext cx="10698480" cy="320040"/>
           </a:xfrm>
           <a:prstGeom prst="rect">
             <a:avLst/>
@@ -6766,13 +6766,13 @@
           <a:lstStyle/>
           <a:p>
             <a:r>
-              <a:rPr sz="900">
+              <a:rPr sz="1100">
                 <a:solidFill>
                   <a:srgbClr val="555A60"/>
                 </a:solidFill>
                 <a:latin typeface="Malgun Gothic"/>
               </a:rPr>
-              <a:t>CUSTOMER-FACING MASTER · FINAL IDENTITY REQUIRED · LEGAL REVIEW REQUIRED · NOT YET SENT  ·  제안 제공자 정보는 발송 전 최종 확정</a:t>
+              <a:t>DRAFT MASTER · LEGAL REVIEW REQUIRED</a:t>
             </a:r>
           </a:p>
         </p:txBody>
@@ -7039,7 +7039,7 @@
         <p:spPr>
           <a:xfrm>
             <a:off x="502920" y="6446520"/>
-            <a:ext cx="8686800" cy="320040"/>
+            <a:ext cx="10698480" cy="320040"/>
           </a:xfrm>
           <a:prstGeom prst="rect">
             <a:avLst/>
@@ -7053,13 +7053,13 @@
           <a:lstStyle/>
           <a:p>
             <a:r>
-              <a:rPr sz="900">
+              <a:rPr sz="1100">
                 <a:solidFill>
                   <a:srgbClr val="555A60"/>
                 </a:solidFill>
                 <a:latin typeface="Malgun Gothic"/>
               </a:rPr>
-              <a:t>CUSTOMER-FACING MASTER · FINAL IDENTITY REQUIRED · LEGAL REVIEW REQUIRED · NOT YET SENT  ·  제안 제공자 정보는 발송 전 최종 확정</a:t>
+              <a:t>DRAFT MASTER · LEGAL REVIEW REQUIRED</a:t>
             </a:r>
           </a:p>
         </p:txBody>
@@ -7326,7 +7326,7 @@
         <p:spPr>
           <a:xfrm>
             <a:off x="502920" y="6446520"/>
-            <a:ext cx="8686800" cy="320040"/>
+            <a:ext cx="10698480" cy="320040"/>
           </a:xfrm>
           <a:prstGeom prst="rect">
             <a:avLst/>
@@ -7340,13 +7340,13 @@
           <a:lstStyle/>
           <a:p>
             <a:r>
-              <a:rPr sz="900">
+              <a:rPr sz="1100">
                 <a:solidFill>
                   <a:srgbClr val="555A60"/>
                 </a:solidFill>
                 <a:latin typeface="Malgun Gothic"/>
               </a:rPr>
-              <a:t>CUSTOMER-FACING MASTER · FINAL IDENTITY REQUIRED · LEGAL REVIEW REQUIRED · NOT YET SENT  ·  제안 제공자 정보는 발송 전 최종 확정</a:t>
+              <a:t>DRAFT MASTER · LEGAL REVIEW REQUIRED</a:t>
             </a:r>
           </a:p>
         </p:txBody>
@@ -8266,7 +8266,7 @@
         <p:spPr>
           <a:xfrm>
             <a:off x="502920" y="6446520"/>
-            <a:ext cx="8686800" cy="320040"/>
+            <a:ext cx="10698480" cy="320040"/>
           </a:xfrm>
           <a:prstGeom prst="rect">
             <a:avLst/>
@@ -8280,13 +8280,13 @@
           <a:lstStyle/>
           <a:p>
             <a:r>
-              <a:rPr sz="900">
+              <a:rPr sz="1100">
                 <a:solidFill>
                   <a:srgbClr val="555A60"/>
                 </a:solidFill>
                 <a:latin typeface="Malgun Gothic"/>
               </a:rPr>
-              <a:t>CUSTOMER-FACING MASTER · FINAL IDENTITY REQUIRED · LEGAL REVIEW REQUIRED · NOT YET SENT  ·  제안 제공자 정보는 발송 전 최종 확정</a:t>
+              <a:t>DRAFT MASTER · LEGAL REVIEW REQUIRED</a:t>
             </a:r>
           </a:p>
         </p:txBody>
@@ -8851,7 +8851,7 @@
         <p:spPr>
           <a:xfrm>
             <a:off x="502920" y="6446520"/>
-            <a:ext cx="8686800" cy="320040"/>
+            <a:ext cx="10698480" cy="320040"/>
           </a:xfrm>
           <a:prstGeom prst="rect">
             <a:avLst/>
@@ -8865,13 +8865,13 @@
           <a:lstStyle/>
           <a:p>
             <a:r>
-              <a:rPr sz="900">
+              <a:rPr sz="1100">
                 <a:solidFill>
                   <a:srgbClr val="555A60"/>
                 </a:solidFill>
                 <a:latin typeface="Malgun Gothic"/>
               </a:rPr>
-              <a:t>CUSTOMER-FACING MASTER · FINAL IDENTITY REQUIRED · LEGAL REVIEW REQUIRED · NOT YET SENT  ·  제안 제공자 정보는 발송 전 최종 확정</a:t>
+              <a:t>DRAFT MASTER · LEGAL REVIEW REQUIRED</a:t>
             </a:r>
           </a:p>
         </p:txBody>

</xml_diff>

<commit_message>
docs(ai-media-education-dx): integrate reviewed reference elements into customer package
Structural/text-based integration of the G-drive reviewed reference package.

Adopted (text/structure level, clearly better):
- Slide number badges (01-10)
- Headline summary under each title
- Slide 1 A/B/C cards (수작업/개인별 AI/기준 부재)
- Slide 5/6 product cards (duration/price + outputs/flow)
- Slide 9 price 4-card ladder (A/B/B/C)
- Slide 10 step descriptions
- One-page 2-column layout (문제/방식 | 상품 A/B/C) + B 표준 가격

Rejected: reference's repeated full footer on every page (current cover/inner/last is better); pixel-level design elements (not viewable by this model).

Added REFERENCE_COMPARISON.md; validator price check updated to range bounds.

Validation: ALL CHECKS PASSED; git diff --check clean; PDF 10/1/4; render 15.

Refs #359.
</commit_message>
<xml_diff>
--- a/docs/commercial/business-35-ai-media-education-dx/customer-package/Business35_Master_Proposal_10p.pptx
+++ b/docs/commercial/business-35-ai-media-education-dx/customer-package/Business35_Master_Proposal_10p.pptx
@@ -4366,7 +4366,115 @@
       </p:sp>
       <p:sp>
         <p:nvSpPr>
-          <p:cNvPr id="4" name="TextBox 3"/>
+          <p:cNvPr id="4" name="Rounded Rectangle 3"/>
+          <p:cNvSpPr/>
+          <p:nvPr/>
+        </p:nvSpPr>
+        <p:spPr>
+          <a:xfrm>
+            <a:off x="11018520" y="256032"/>
+            <a:ext cx="868680" cy="548640"/>
+          </a:xfrm>
+          <a:prstGeom prst="roundRect">
+            <a:avLst/>
+          </a:prstGeom>
+          <a:solidFill>
+            <a:srgbClr val="C27B2D"/>
+          </a:solidFill>
+          <a:ln>
+            <a:noFill/>
+          </a:ln>
+          <a:effectLst/>
+        </p:spPr>
+        <p:style>
+          <a:lnRef idx="1">
+            <a:schemeClr val="accent1"/>
+          </a:lnRef>
+          <a:fillRef idx="3">
+            <a:schemeClr val="accent1"/>
+          </a:fillRef>
+          <a:effectRef idx="2">
+            <a:schemeClr val="accent1"/>
+          </a:effectRef>
+          <a:fontRef idx="minor">
+            <a:schemeClr val="lt1"/>
+          </a:fontRef>
+        </p:style>
+        <p:txBody>
+          <a:bodyPr rtlCol="0" anchor="ctr"/>
+          <a:lstStyle/>
+          <a:p>
+            <a:pPr algn="ctr"/>
+            <a:r>
+              <a:rPr sz="1800" b="1">
+                <a:solidFill>
+                  <a:srgbClr val="FFFFFF"/>
+                </a:solidFill>
+                <a:latin typeface="Malgun Gothic"/>
+              </a:rPr>
+              <a:t>01</a:t>
+            </a:r>
+          </a:p>
+        </p:txBody>
+      </p:sp>
+      <p:sp>
+        <p:nvSpPr>
+          <p:cNvPr id="5" name="Rectangle 4"/>
+          <p:cNvSpPr/>
+          <p:nvPr/>
+        </p:nvSpPr>
+        <p:spPr>
+          <a:xfrm>
+            <a:off x="640080" y="1188720"/>
+            <a:ext cx="10881360" cy="566928"/>
+          </a:xfrm>
+          <a:prstGeom prst="rect">
+            <a:avLst/>
+          </a:prstGeom>
+          <a:solidFill>
+            <a:srgbClr val="E3E9F0"/>
+          </a:solidFill>
+          <a:ln w="9525">
+            <a:solidFill>
+              <a:srgbClr val="2E5E8C"/>
+            </a:solidFill>
+          </a:ln>
+          <a:effectLst/>
+        </p:spPr>
+        <p:style>
+          <a:lnRef idx="1">
+            <a:schemeClr val="accent1"/>
+          </a:lnRef>
+          <a:fillRef idx="3">
+            <a:schemeClr val="accent1"/>
+          </a:fillRef>
+          <a:effectRef idx="2">
+            <a:schemeClr val="accent1"/>
+          </a:effectRef>
+          <a:fontRef idx="minor">
+            <a:schemeClr val="lt1"/>
+          </a:fontRef>
+        </p:style>
+        <p:txBody>
+          <a:bodyPr rtlCol="0" anchor="ctr" wrap="square" lIns="182880"/>
+          <a:lstStyle/>
+          <a:p>
+            <a:pPr algn="ctr"/>
+            <a:r>
+              <a:rPr sz="1500" b="1">
+                <a:solidFill>
+                  <a:srgbClr val="1F3A5F"/>
+                </a:solidFill>
+                <a:latin typeface="Malgun Gothic"/>
+              </a:rPr>
+              <a:t>콘텐츠 제작은 늘었지만 조직의 기준과 검토체계는 따라오지 못합니다.</a:t>
+            </a:r>
+          </a:p>
+        </p:txBody>
+      </p:sp>
+      <p:sp>
+        <p:nvSpPr>
+          <p:cNvPr id="6" name="TextBox 5"/>
           <p:cNvSpPr txBox="1"/>
           <p:nvPr/>
         </p:nvSpPr>
@@ -4400,150 +4508,248 @@
       </p:sp>
       <p:sp>
         <p:nvSpPr>
-          <p:cNvPr id="5" name="TextBox 4"/>
-          <p:cNvSpPr txBox="1"/>
-          <p:nvPr/>
-        </p:nvSpPr>
-        <p:spPr>
-          <a:xfrm>
-            <a:off x="640080" y="1371600"/>
-            <a:ext cx="10881360" cy="4754880"/>
-          </a:xfrm>
-          <a:prstGeom prst="rect">
-            <a:avLst/>
-          </a:prstGeom>
-          <a:noFill/>
-        </p:spPr>
-        <p:txBody>
-          <a:bodyPr wrap="square">
-            <a:spAutoFit/>
-          </a:bodyPr>
-          <a:lstStyle/>
-          <a:p>
-            <a:pPr>
-              <a:spcAft>
-                <a:spcPts val="600"/>
-              </a:spcAft>
+          <p:cNvPr id="7" name="Rounded Rectangle 6"/>
+          <p:cNvSpPr/>
+          <p:nvPr/>
+        </p:nvSpPr>
+        <p:spPr>
+          <a:xfrm>
+            <a:off x="640080" y="1828800"/>
+            <a:ext cx="3520440" cy="2926080"/>
+          </a:xfrm>
+          <a:prstGeom prst="roundRect">
+            <a:avLst/>
+          </a:prstGeom>
+          <a:solidFill>
+            <a:srgbClr val="FFFFFF"/>
+          </a:solidFill>
+          <a:ln w="12700">
+            <a:solidFill>
+              <a:srgbClr val="2E5E8C"/>
+            </a:solidFill>
+          </a:ln>
+          <a:effectLst/>
+        </p:spPr>
+        <p:style>
+          <a:lnRef idx="1">
+            <a:schemeClr val="accent1"/>
+          </a:lnRef>
+          <a:fillRef idx="3">
+            <a:schemeClr val="accent1"/>
+          </a:fillRef>
+          <a:effectRef idx="2">
+            <a:schemeClr val="accent1"/>
+          </a:effectRef>
+          <a:fontRef idx="minor">
+            <a:schemeClr val="lt1"/>
+          </a:fontRef>
+        </p:style>
+        <p:txBody>
+          <a:bodyPr rtlCol="0" anchor="ctr" wrap="square" lIns="182880" rIns="182880" tIns="228600"/>
+          <a:lstStyle/>
+          <a:p>
+            <a:pPr algn="ctr"/>
+            <a:r>
+              <a:rPr sz="2600" b="1">
+                <a:solidFill>
+                  <a:srgbClr val="C27B2D"/>
+                </a:solidFill>
+                <a:latin typeface="Malgun Gothic"/>
+              </a:rPr>
+              <a:t>A</a:t>
+            </a:r>
+          </a:p>
+          <a:p>
+            <a:pPr algn="ctr"/>
+            <a:r>
+              <a:rPr sz="1900" b="1">
+                <a:solidFill>
+                  <a:srgbClr val="1F3A5F"/>
+                </a:solidFill>
+                <a:latin typeface="Malgun Gothic"/>
+              </a:rPr>
+              <a:t>수작업 제작</a:t>
+            </a:r>
+          </a:p>
+          <a:p>
+            <a:pPr algn="ctr">
+              <a:spcBef>
+                <a:spcPts val="1000"/>
+              </a:spcBef>
             </a:pPr>
             <a:r>
-              <a:rPr sz="2000" b="1">
+              <a:rPr sz="1400">
+                <a:solidFill>
+                  <a:srgbClr val="555A60"/>
+                </a:solidFill>
+                <a:latin typeface="Malgun Gothic"/>
+              </a:rPr>
+              <a:t>홍보물·안내문·뉴스레터 초안이 개인 경험과 수동 검토에 의존합니다.</a:t>
+            </a:r>
+          </a:p>
+        </p:txBody>
+      </p:sp>
+      <p:sp>
+        <p:nvSpPr>
+          <p:cNvPr id="8" name="Rounded Rectangle 7"/>
+          <p:cNvSpPr/>
+          <p:nvPr/>
+        </p:nvSpPr>
+        <p:spPr>
+          <a:xfrm>
+            <a:off x="4389119" y="1828800"/>
+            <a:ext cx="3520440" cy="2926080"/>
+          </a:xfrm>
+          <a:prstGeom prst="roundRect">
+            <a:avLst/>
+          </a:prstGeom>
+          <a:solidFill>
+            <a:srgbClr val="FFFFFF"/>
+          </a:solidFill>
+          <a:ln w="12700">
+            <a:solidFill>
+              <a:srgbClr val="2E5E8C"/>
+            </a:solidFill>
+          </a:ln>
+          <a:effectLst/>
+        </p:spPr>
+        <p:style>
+          <a:lnRef idx="1">
+            <a:schemeClr val="accent1"/>
+          </a:lnRef>
+          <a:fillRef idx="3">
+            <a:schemeClr val="accent1"/>
+          </a:fillRef>
+          <a:effectRef idx="2">
+            <a:schemeClr val="accent1"/>
+          </a:effectRef>
+          <a:fontRef idx="minor">
+            <a:schemeClr val="lt1"/>
+          </a:fontRef>
+        </p:style>
+        <p:txBody>
+          <a:bodyPr rtlCol="0" anchor="ctr" wrap="square" lIns="182880" rIns="182880" tIns="228600"/>
+          <a:lstStyle/>
+          <a:p>
+            <a:pPr algn="ctr"/>
+            <a:r>
+              <a:rPr sz="2600" b="1">
+                <a:solidFill>
+                  <a:srgbClr val="C27B2D"/>
+                </a:solidFill>
+                <a:latin typeface="Malgun Gothic"/>
+              </a:rPr>
+              <a:t>B</a:t>
+            </a:r>
+          </a:p>
+          <a:p>
+            <a:pPr algn="ctr"/>
+            <a:r>
+              <a:rPr sz="1900" b="1">
                 <a:solidFill>
                   <a:srgbClr val="1F3A5F"/>
                 </a:solidFill>
                 <a:latin typeface="Malgun Gothic"/>
               </a:rPr>
-              <a:t>콘텐츠 제작·검토가 수작업</a:t>
-            </a:r>
-          </a:p>
-          <a:p>
-            <a:pPr>
-              <a:spcAft>
-                <a:spcPts val="600"/>
-              </a:spcAft>
+              <a:t>개인별 AI 사용</a:t>
+            </a:r>
+          </a:p>
+          <a:p>
+            <a:pPr algn="ctr">
+              <a:spcBef>
+                <a:spcPts val="1000"/>
+              </a:spcBef>
             </a:pPr>
             <a:r>
-              <a:rPr sz="1600" b="0">
+              <a:rPr sz="1400">
                 <a:solidFill>
                   <a:srgbClr val="555A60"/>
                 </a:solidFill>
                 <a:latin typeface="Malgun Gothic"/>
               </a:rPr>
-              <a:t>홍보물·안내문·뉴스레터를 만드는 데 여러 단계의 수동 검토가 걸립니다.</a:t>
-            </a:r>
-          </a:p>
-          <a:p>
-            <a:pPr>
-              <a:spcAft>
-                <a:spcPts val="600"/>
-              </a:spcAft>
+              <a:t>조직원마다 개인적으로 AI를 쓰지만 조직 차원의 기준은 없습니다.</a:t>
+            </a:r>
+          </a:p>
+        </p:txBody>
+      </p:sp>
+      <p:sp>
+        <p:nvSpPr>
+          <p:cNvPr id="9" name="Rounded Rectangle 8"/>
+          <p:cNvSpPr/>
+          <p:nvPr/>
+        </p:nvSpPr>
+        <p:spPr>
+          <a:xfrm>
+            <a:off x="8138158" y="1828800"/>
+            <a:ext cx="3520440" cy="2926080"/>
+          </a:xfrm>
+          <a:prstGeom prst="roundRect">
+            <a:avLst/>
+          </a:prstGeom>
+          <a:solidFill>
+            <a:srgbClr val="FFFFFF"/>
+          </a:solidFill>
+          <a:ln w="12700">
+            <a:solidFill>
+              <a:srgbClr val="2E5E8C"/>
+            </a:solidFill>
+          </a:ln>
+          <a:effectLst/>
+        </p:spPr>
+        <p:style>
+          <a:lnRef idx="1">
+            <a:schemeClr val="accent1"/>
+          </a:lnRef>
+          <a:fillRef idx="3">
+            <a:schemeClr val="accent1"/>
+          </a:fillRef>
+          <a:effectRef idx="2">
+            <a:schemeClr val="accent1"/>
+          </a:effectRef>
+          <a:fontRef idx="minor">
+            <a:schemeClr val="lt1"/>
+          </a:fontRef>
+        </p:style>
+        <p:txBody>
+          <a:bodyPr rtlCol="0" anchor="ctr" wrap="square" lIns="182880" rIns="182880" tIns="228600"/>
+          <a:lstStyle/>
+          <a:p>
+            <a:pPr algn="ctr"/>
+            <a:r>
+              <a:rPr sz="2600" b="1">
+                <a:solidFill>
+                  <a:srgbClr val="C27B2D"/>
+                </a:solidFill>
+                <a:latin typeface="Malgun Gothic"/>
+              </a:rPr>
+              <a:t>C</a:t>
+            </a:r>
+          </a:p>
+          <a:p>
+            <a:pPr algn="ctr"/>
+            <a:r>
+              <a:rPr sz="1900" b="1">
+                <a:solidFill>
+                  <a:srgbClr val="1F3A5F"/>
+                </a:solidFill>
+                <a:latin typeface="Malgun Gothic"/>
+              </a:rPr>
+              <a:t>검토 기준 부재</a:t>
+            </a:r>
+          </a:p>
+          <a:p>
+            <a:pPr algn="ctr">
+              <a:spcBef>
+                <a:spcPts val="1000"/>
+              </a:spcBef>
             </a:pPr>
             <a:r>
-              <a:rPr sz="800" b="0">
+              <a:rPr sz="1400">
                 <a:solidFill>
                   <a:srgbClr val="555A60"/>
                 </a:solidFill>
                 <a:latin typeface="Malgun Gothic"/>
               </a:rPr>
-              <a:t/>
-            </a:r>
-          </a:p>
-          <a:p>
-            <a:pPr>
-              <a:spcAft>
-                <a:spcPts val="600"/>
-              </a:spcAft>
-            </a:pPr>
-            <a:r>
-              <a:rPr sz="2000" b="1">
-                <a:solidFill>
-                  <a:srgbClr val="1F3A5F"/>
-                </a:solidFill>
-                <a:latin typeface="Malgun Gothic"/>
-              </a:rPr>
-              <a:t>AI 사용이 개인 단위</a:t>
-            </a:r>
-          </a:p>
-          <a:p>
-            <a:pPr>
-              <a:spcAft>
-                <a:spcPts val="600"/>
-              </a:spcAft>
-            </a:pPr>
-            <a:r>
-              <a:rPr sz="1600" b="0">
-                <a:solidFill>
-                  <a:srgbClr val="555A60"/>
-                </a:solidFill>
-                <a:latin typeface="Malgun Gothic"/>
-              </a:rPr>
-              <a:t>조직원마다 개인적으로 AI 도구를 쓰지만, 조직 차원의 기준은 없습니다.</a:t>
-            </a:r>
-          </a:p>
-          <a:p>
-            <a:pPr>
-              <a:spcAft>
-                <a:spcPts val="600"/>
-              </a:spcAft>
-            </a:pPr>
-            <a:r>
-              <a:rPr sz="800" b="0">
-                <a:solidFill>
-                  <a:srgbClr val="555A60"/>
-                </a:solidFill>
-                <a:latin typeface="Malgun Gothic"/>
-              </a:rPr>
-              <a:t/>
-            </a:r>
-          </a:p>
-          <a:p>
-            <a:pPr>
-              <a:spcAft>
-                <a:spcPts val="600"/>
-              </a:spcAft>
-            </a:pPr>
-            <a:r>
-              <a:rPr sz="2000" b="1">
-                <a:solidFill>
-                  <a:srgbClr val="1F3A5F"/>
-                </a:solidFill>
-                <a:latin typeface="Malgun Gothic"/>
-              </a:rPr>
-              <a:t>조직 기준 부재</a:t>
-            </a:r>
-          </a:p>
-          <a:p>
-            <a:pPr>
-              <a:spcAft>
-                <a:spcPts val="600"/>
-              </a:spcAft>
-            </a:pPr>
-            <a:r>
-              <a:rPr sz="1600" b="0">
-                <a:solidFill>
-                  <a:srgbClr val="555A60"/>
-                </a:solidFill>
-                <a:latin typeface="Malgun Gothic"/>
-              </a:rPr>
               <a:t>검토·승인 기준, 사용정책, 금지 업무 규칙이 없어 위험이 커집니다.</a:t>
             </a:r>
           </a:p>
@@ -4551,7 +4757,7 @@
       </p:sp>
       <p:sp>
         <p:nvSpPr>
-          <p:cNvPr id="6" name="TextBox 5"/>
+          <p:cNvPr id="10" name="TextBox 9"/>
           <p:cNvSpPr txBox="1"/>
           <p:nvPr/>
         </p:nvSpPr>
@@ -4701,7 +4907,115 @@
       </p:sp>
       <p:sp>
         <p:nvSpPr>
-          <p:cNvPr id="4" name="TextBox 3"/>
+          <p:cNvPr id="4" name="Rounded Rectangle 3"/>
+          <p:cNvSpPr/>
+          <p:nvPr/>
+        </p:nvSpPr>
+        <p:spPr>
+          <a:xfrm>
+            <a:off x="11018520" y="256032"/>
+            <a:ext cx="868680" cy="548640"/>
+          </a:xfrm>
+          <a:prstGeom prst="roundRect">
+            <a:avLst/>
+          </a:prstGeom>
+          <a:solidFill>
+            <a:srgbClr val="C27B2D"/>
+          </a:solidFill>
+          <a:ln>
+            <a:noFill/>
+          </a:ln>
+          <a:effectLst/>
+        </p:spPr>
+        <p:style>
+          <a:lnRef idx="1">
+            <a:schemeClr val="accent1"/>
+          </a:lnRef>
+          <a:fillRef idx="3">
+            <a:schemeClr val="accent1"/>
+          </a:fillRef>
+          <a:effectRef idx="2">
+            <a:schemeClr val="accent1"/>
+          </a:effectRef>
+          <a:fontRef idx="minor">
+            <a:schemeClr val="lt1"/>
+          </a:fontRef>
+        </p:style>
+        <p:txBody>
+          <a:bodyPr rtlCol="0" anchor="ctr"/>
+          <a:lstStyle/>
+          <a:p>
+            <a:pPr algn="ctr"/>
+            <a:r>
+              <a:rPr sz="1800" b="1">
+                <a:solidFill>
+                  <a:srgbClr val="FFFFFF"/>
+                </a:solidFill>
+                <a:latin typeface="Malgun Gothic"/>
+              </a:rPr>
+              <a:t>10</a:t>
+            </a:r>
+          </a:p>
+        </p:txBody>
+      </p:sp>
+      <p:sp>
+        <p:nvSpPr>
+          <p:cNvPr id="5" name="Rectangle 4"/>
+          <p:cNvSpPr/>
+          <p:nvPr/>
+        </p:nvSpPr>
+        <p:spPr>
+          <a:xfrm>
+            <a:off x="640080" y="1188720"/>
+            <a:ext cx="10881360" cy="566928"/>
+          </a:xfrm>
+          <a:prstGeom prst="rect">
+            <a:avLst/>
+          </a:prstGeom>
+          <a:solidFill>
+            <a:srgbClr val="E3E9F0"/>
+          </a:solidFill>
+          <a:ln w="9525">
+            <a:solidFill>
+              <a:srgbClr val="2E5E8C"/>
+            </a:solidFill>
+          </a:ln>
+          <a:effectLst/>
+        </p:spPr>
+        <p:style>
+          <a:lnRef idx="1">
+            <a:schemeClr val="accent1"/>
+          </a:lnRef>
+          <a:fillRef idx="3">
+            <a:schemeClr val="accent1"/>
+          </a:fillRef>
+          <a:effectRef idx="2">
+            <a:schemeClr val="accent1"/>
+          </a:effectRef>
+          <a:fontRef idx="minor">
+            <a:schemeClr val="lt1"/>
+          </a:fontRef>
+        </p:style>
+        <p:txBody>
+          <a:bodyPr rtlCol="0" anchor="ctr" wrap="square" lIns="182880"/>
+          <a:lstStyle/>
+          <a:p>
+            <a:pPr algn="ctr"/>
+            <a:r>
+              <a:rPr sz="1500" b="1">
+                <a:solidFill>
+                  <a:srgbClr val="1F3A5F"/>
+                </a:solidFill>
+                <a:latin typeface="Malgun Gothic"/>
+              </a:rPr>
+              <a:t>30분 상담에서 대상 업무 하나를 정하고, 워크숍 범위를 확정합니다.</a:t>
+            </a:r>
+          </a:p>
+        </p:txBody>
+      </p:sp>
+      <p:sp>
+        <p:nvSpPr>
+          <p:cNvPr id="6" name="TextBox 5"/>
           <p:cNvSpPr txBox="1"/>
           <p:nvPr/>
         </p:nvSpPr>
@@ -4735,14 +5049,14 @@
       </p:sp>
       <p:sp>
         <p:nvSpPr>
-          <p:cNvPr id="5" name="Rounded Rectangle 4"/>
+          <p:cNvPr id="7" name="Rounded Rectangle 6"/>
           <p:cNvSpPr/>
           <p:nvPr/>
         </p:nvSpPr>
         <p:spPr>
           <a:xfrm>
             <a:off x="640080" y="2194560"/>
-            <a:ext cx="2468880" cy="2011680"/>
+            <a:ext cx="2468880" cy="2194560"/>
           </a:xfrm>
           <a:prstGeom prst="roundRect">
             <a:avLst/>
@@ -4788,7 +5102,7 @@
           <a:p>
             <a:pPr algn="ctr"/>
             <a:r>
-              <a:rPr sz="1500">
+              <a:rPr sz="1500" b="1">
                 <a:solidFill>
                   <a:srgbClr val="FFFFFF"/>
                 </a:solidFill>
@@ -4797,18 +5111,30 @@
               <a:t>30분 사전 상담</a:t>
             </a:r>
           </a:p>
-        </p:txBody>
-      </p:sp>
-      <p:sp>
-        <p:nvSpPr>
-          <p:cNvPr id="6" name="Rounded Rectangle 5"/>
+          <a:p>
+            <a:pPr algn="ctr"/>
+            <a:r>
+              <a:rPr sz="1100">
+                <a:solidFill>
+                  <a:srgbClr val="D5DEE8"/>
+                </a:solidFill>
+                <a:latin typeface="Malgun Gothic"/>
+              </a:rPr>
+              <a:t>현재 업무 흐름과 위험 확인</a:t>
+            </a:r>
+          </a:p>
+        </p:txBody>
+      </p:sp>
+      <p:sp>
+        <p:nvSpPr>
+          <p:cNvPr id="8" name="Rounded Rectangle 7"/>
           <p:cNvSpPr/>
           <p:nvPr/>
         </p:nvSpPr>
         <p:spPr>
           <a:xfrm>
             <a:off x="3474720" y="2194560"/>
-            <a:ext cx="2468880" cy="2011680"/>
+            <a:ext cx="2468880" cy="2194560"/>
           </a:xfrm>
           <a:prstGeom prst="roundRect">
             <a:avLst/>
@@ -4854,7 +5180,7 @@
           <a:p>
             <a:pPr algn="ctr"/>
             <a:r>
-              <a:rPr sz="1500">
+              <a:rPr sz="1500" b="1">
                 <a:solidFill>
                   <a:srgbClr val="FFFFFF"/>
                 </a:solidFill>
@@ -4863,18 +5189,30 @@
               <a:t>대상 업무 1개 선정</a:t>
             </a:r>
           </a:p>
-        </p:txBody>
-      </p:sp>
-      <p:sp>
-        <p:nvSpPr>
-          <p:cNvPr id="7" name="Rounded Rectangle 6"/>
+          <a:p>
+            <a:pPr algn="ctr"/>
+            <a:r>
+              <a:rPr sz="1100">
+                <a:solidFill>
+                  <a:srgbClr val="D5DEE8"/>
+                </a:solidFill>
+                <a:latin typeface="Malgun Gothic"/>
+              </a:rPr>
+              <a:t>홍보·교육·콘텐츠 중 하나</a:t>
+            </a:r>
+          </a:p>
+        </p:txBody>
+      </p:sp>
+      <p:sp>
+        <p:nvSpPr>
+          <p:cNvPr id="9" name="Rounded Rectangle 8"/>
           <p:cNvSpPr/>
           <p:nvPr/>
         </p:nvSpPr>
         <p:spPr>
           <a:xfrm>
             <a:off x="6309360" y="2194560"/>
-            <a:ext cx="2468880" cy="2011680"/>
+            <a:ext cx="2468880" cy="2194560"/>
           </a:xfrm>
           <a:prstGeom prst="roundRect">
             <a:avLst/>
@@ -4920,7 +5258,7 @@
           <a:p>
             <a:pPr algn="ctr"/>
             <a:r>
-              <a:rPr sz="1500">
+              <a:rPr sz="1500" b="1">
                 <a:solidFill>
                   <a:srgbClr val="FFFFFF"/>
                 </a:solidFill>
@@ -4929,18 +5267,30 @@
               <a:t>진단 워크숍 범위 확정</a:t>
             </a:r>
           </a:p>
-        </p:txBody>
-      </p:sp>
-      <p:sp>
-        <p:nvSpPr>
-          <p:cNvPr id="8" name="Rounded Rectangle 7"/>
+          <a:p>
+            <a:pPr algn="ctr"/>
+            <a:r>
+              <a:rPr sz="1100">
+                <a:solidFill>
+                  <a:srgbClr val="D5DEE8"/>
+                </a:solidFill>
+                <a:latin typeface="Malgun Gothic"/>
+              </a:rPr>
+              <a:t>참여자·일정·자료 범위</a:t>
+            </a:r>
+          </a:p>
+        </p:txBody>
+      </p:sp>
+      <p:sp>
+        <p:nvSpPr>
+          <p:cNvPr id="10" name="Rounded Rectangle 9"/>
           <p:cNvSpPr/>
           <p:nvPr/>
         </p:nvSpPr>
         <p:spPr>
           <a:xfrm>
             <a:off x="9144000" y="2194560"/>
-            <a:ext cx="2468880" cy="2011680"/>
+            <a:ext cx="2468880" cy="2194560"/>
           </a:xfrm>
           <a:prstGeom prst="roundRect">
             <a:avLst/>
@@ -4986,7 +5336,7 @@
           <a:p>
             <a:pPr algn="ctr"/>
             <a:r>
-              <a:rPr sz="1500">
+              <a:rPr sz="1500" b="1">
                 <a:solidFill>
                   <a:srgbClr val="FFFFFF"/>
                 </a:solidFill>
@@ -4995,11 +5345,23 @@
               <a:t>견적·일정 승인</a:t>
             </a:r>
           </a:p>
-        </p:txBody>
-      </p:sp>
-      <p:sp>
-        <p:nvSpPr>
-          <p:cNvPr id="9" name="TextBox 8"/>
+          <a:p>
+            <a:pPr algn="ctr"/>
+            <a:r>
+              <a:rPr sz="1100">
+                <a:solidFill>
+                  <a:srgbClr val="D5DEE8"/>
+                </a:solidFill>
+                <a:latin typeface="Malgun Gothic"/>
+              </a:rPr>
+              <a:t>가격 가설 기반 최종 견적</a:t>
+            </a:r>
+          </a:p>
+        </p:txBody>
+      </p:sp>
+      <p:sp>
+        <p:nvSpPr>
+          <p:cNvPr id="11" name="TextBox 10"/>
           <p:cNvSpPr txBox="1"/>
           <p:nvPr/>
         </p:nvSpPr>
@@ -5054,7 +5416,7 @@
       </p:sp>
       <p:sp>
         <p:nvSpPr>
-          <p:cNvPr id="10" name="TextBox 9"/>
+          <p:cNvPr id="12" name="TextBox 11"/>
           <p:cNvSpPr txBox="1"/>
           <p:nvPr/>
         </p:nvSpPr>
@@ -5204,7 +5566,115 @@
       </p:sp>
       <p:sp>
         <p:nvSpPr>
-          <p:cNvPr id="4" name="TextBox 3"/>
+          <p:cNvPr id="4" name="Rounded Rectangle 3"/>
+          <p:cNvSpPr/>
+          <p:nvPr/>
+        </p:nvSpPr>
+        <p:spPr>
+          <a:xfrm>
+            <a:off x="11018520" y="256032"/>
+            <a:ext cx="868680" cy="548640"/>
+          </a:xfrm>
+          <a:prstGeom prst="roundRect">
+            <a:avLst/>
+          </a:prstGeom>
+          <a:solidFill>
+            <a:srgbClr val="C27B2D"/>
+          </a:solidFill>
+          <a:ln>
+            <a:noFill/>
+          </a:ln>
+          <a:effectLst/>
+        </p:spPr>
+        <p:style>
+          <a:lnRef idx="1">
+            <a:schemeClr val="accent1"/>
+          </a:lnRef>
+          <a:fillRef idx="3">
+            <a:schemeClr val="accent1"/>
+          </a:fillRef>
+          <a:effectRef idx="2">
+            <a:schemeClr val="accent1"/>
+          </a:effectRef>
+          <a:fontRef idx="minor">
+            <a:schemeClr val="lt1"/>
+          </a:fontRef>
+        </p:style>
+        <p:txBody>
+          <a:bodyPr rtlCol="0" anchor="ctr"/>
+          <a:lstStyle/>
+          <a:p>
+            <a:pPr algn="ctr"/>
+            <a:r>
+              <a:rPr sz="1800" b="1">
+                <a:solidFill>
+                  <a:srgbClr val="FFFFFF"/>
+                </a:solidFill>
+                <a:latin typeface="Malgun Gothic"/>
+              </a:rPr>
+              <a:t>02</a:t>
+            </a:r>
+          </a:p>
+        </p:txBody>
+      </p:sp>
+      <p:sp>
+        <p:nvSpPr>
+          <p:cNvPr id="5" name="Rectangle 4"/>
+          <p:cNvSpPr/>
+          <p:nvPr/>
+        </p:nvSpPr>
+        <p:spPr>
+          <a:xfrm>
+            <a:off x="640080" y="1188720"/>
+            <a:ext cx="10881360" cy="566928"/>
+          </a:xfrm>
+          <a:prstGeom prst="rect">
+            <a:avLst/>
+          </a:prstGeom>
+          <a:solidFill>
+            <a:srgbClr val="E3E9F0"/>
+          </a:solidFill>
+          <a:ln w="9525">
+            <a:solidFill>
+              <a:srgbClr val="2E5E8C"/>
+            </a:solidFill>
+          </a:ln>
+          <a:effectLst/>
+        </p:spPr>
+        <p:style>
+          <a:lnRef idx="1">
+            <a:schemeClr val="accent1"/>
+          </a:lnRef>
+          <a:fillRef idx="3">
+            <a:schemeClr val="accent1"/>
+          </a:fillRef>
+          <a:effectRef idx="2">
+            <a:schemeClr val="accent1"/>
+          </a:effectRef>
+          <a:fontRef idx="minor">
+            <a:schemeClr val="lt1"/>
+          </a:fontRef>
+        </p:style>
+        <p:txBody>
+          <a:bodyPr rtlCol="0" anchor="ctr" wrap="square" lIns="182880"/>
+          <a:lstStyle/>
+          <a:p>
+            <a:pPr algn="ctr"/>
+            <a:r>
+              <a:rPr sz="1500" b="1">
+                <a:solidFill>
+                  <a:srgbClr val="1F3A5F"/>
+                </a:solidFill>
+                <a:latin typeface="Malgun Gothic"/>
+              </a:rPr>
+              <a:t>교육 수료와 실제 업무 전환은 다릅니다.</a:t>
+            </a:r>
+          </a:p>
+        </p:txBody>
+      </p:sp>
+      <p:sp>
+        <p:nvSpPr>
+          <p:cNvPr id="6" name="TextBox 5"/>
           <p:cNvSpPr txBox="1"/>
           <p:nvPr/>
         </p:nvSpPr>
@@ -5238,7 +5708,7 @@
       </p:sp>
       <p:sp>
         <p:nvSpPr>
-          <p:cNvPr id="5" name="TextBox 4"/>
+          <p:cNvPr id="7" name="TextBox 6"/>
           <p:cNvSpPr txBox="1"/>
           <p:nvPr/>
         </p:nvSpPr>
@@ -5341,7 +5811,7 @@
       </p:sp>
       <p:sp>
         <p:nvSpPr>
-          <p:cNvPr id="6" name="TextBox 5"/>
+          <p:cNvPr id="8" name="TextBox 7"/>
           <p:cNvSpPr txBox="1"/>
           <p:nvPr/>
         </p:nvSpPr>
@@ -5491,7 +5961,115 @@
       </p:sp>
       <p:sp>
         <p:nvSpPr>
-          <p:cNvPr id="4" name="TextBox 3"/>
+          <p:cNvPr id="4" name="Rounded Rectangle 3"/>
+          <p:cNvSpPr/>
+          <p:nvPr/>
+        </p:nvSpPr>
+        <p:spPr>
+          <a:xfrm>
+            <a:off x="11018520" y="256032"/>
+            <a:ext cx="868680" cy="548640"/>
+          </a:xfrm>
+          <a:prstGeom prst="roundRect">
+            <a:avLst/>
+          </a:prstGeom>
+          <a:solidFill>
+            <a:srgbClr val="C27B2D"/>
+          </a:solidFill>
+          <a:ln>
+            <a:noFill/>
+          </a:ln>
+          <a:effectLst/>
+        </p:spPr>
+        <p:style>
+          <a:lnRef idx="1">
+            <a:schemeClr val="accent1"/>
+          </a:lnRef>
+          <a:fillRef idx="3">
+            <a:schemeClr val="accent1"/>
+          </a:fillRef>
+          <a:effectRef idx="2">
+            <a:schemeClr val="accent1"/>
+          </a:effectRef>
+          <a:fontRef idx="minor">
+            <a:schemeClr val="lt1"/>
+          </a:fontRef>
+        </p:style>
+        <p:txBody>
+          <a:bodyPr rtlCol="0" anchor="ctr"/>
+          <a:lstStyle/>
+          <a:p>
+            <a:pPr algn="ctr"/>
+            <a:r>
+              <a:rPr sz="1800" b="1">
+                <a:solidFill>
+                  <a:srgbClr val="FFFFFF"/>
+                </a:solidFill>
+                <a:latin typeface="Malgun Gothic"/>
+              </a:rPr>
+              <a:t>03</a:t>
+            </a:r>
+          </a:p>
+        </p:txBody>
+      </p:sp>
+      <p:sp>
+        <p:nvSpPr>
+          <p:cNvPr id="5" name="Rectangle 4"/>
+          <p:cNvSpPr/>
+          <p:nvPr/>
+        </p:nvSpPr>
+        <p:spPr>
+          <a:xfrm>
+            <a:off x="640080" y="1188720"/>
+            <a:ext cx="10881360" cy="566928"/>
+          </a:xfrm>
+          <a:prstGeom prst="rect">
+            <a:avLst/>
+          </a:prstGeom>
+          <a:solidFill>
+            <a:srgbClr val="E3E9F0"/>
+          </a:solidFill>
+          <a:ln w="9525">
+            <a:solidFill>
+              <a:srgbClr val="2E5E8C"/>
+            </a:solidFill>
+          </a:ln>
+          <a:effectLst/>
+        </p:spPr>
+        <p:style>
+          <a:lnRef idx="1">
+            <a:schemeClr val="accent1"/>
+          </a:lnRef>
+          <a:fillRef idx="3">
+            <a:schemeClr val="accent1"/>
+          </a:fillRef>
+          <a:effectRef idx="2">
+            <a:schemeClr val="accent1"/>
+          </a:effectRef>
+          <a:fontRef idx="minor">
+            <a:schemeClr val="lt1"/>
+          </a:fontRef>
+        </p:style>
+        <p:txBody>
+          <a:bodyPr rtlCol="0" anchor="ctr" wrap="square" lIns="182880"/>
+          <a:lstStyle/>
+          <a:p>
+            <a:pPr algn="ctr"/>
+            <a:r>
+              <a:rPr sz="1500" b="1">
+                <a:solidFill>
+                  <a:srgbClr val="1F3A5F"/>
+                </a:solidFill>
+                <a:latin typeface="Malgun Gothic"/>
+              </a:rPr>
+              <a:t>진단에서 운영 플레이북까지 이어지는 7단계 업무전환 구조입니다.</a:t>
+            </a:r>
+          </a:p>
+        </p:txBody>
+      </p:sp>
+      <p:sp>
+        <p:nvSpPr>
+          <p:cNvPr id="6" name="TextBox 5"/>
           <p:cNvSpPr txBox="1"/>
           <p:nvPr/>
         </p:nvSpPr>
@@ -5525,7 +6103,7 @@
       </p:sp>
       <p:sp>
         <p:nvSpPr>
-          <p:cNvPr id="5" name="TextBox 4"/>
+          <p:cNvPr id="7" name="TextBox 6"/>
           <p:cNvSpPr txBox="1"/>
           <p:nvPr/>
         </p:nvSpPr>
@@ -5564,7 +6142,7 @@
       </p:sp>
       <p:sp>
         <p:nvSpPr>
-          <p:cNvPr id="6" name="Rounded Rectangle 5"/>
+          <p:cNvPr id="8" name="Rounded Rectangle 7"/>
           <p:cNvSpPr/>
           <p:nvPr/>
         </p:nvSpPr>
@@ -5630,7 +6208,7 @@
       </p:sp>
       <p:sp>
         <p:nvSpPr>
-          <p:cNvPr id="7" name="Rounded Rectangle 6"/>
+          <p:cNvPr id="9" name="Rounded Rectangle 8"/>
           <p:cNvSpPr/>
           <p:nvPr/>
         </p:nvSpPr>
@@ -5696,7 +6274,7 @@
       </p:sp>
       <p:sp>
         <p:nvSpPr>
-          <p:cNvPr id="8" name="Rounded Rectangle 7"/>
+          <p:cNvPr id="10" name="Rounded Rectangle 9"/>
           <p:cNvSpPr/>
           <p:nvPr/>
         </p:nvSpPr>
@@ -5762,7 +6340,7 @@
       </p:sp>
       <p:sp>
         <p:nvSpPr>
-          <p:cNvPr id="9" name="Rounded Rectangle 8"/>
+          <p:cNvPr id="11" name="Rounded Rectangle 10"/>
           <p:cNvSpPr/>
           <p:nvPr/>
         </p:nvSpPr>
@@ -5828,7 +6406,7 @@
       </p:sp>
       <p:sp>
         <p:nvSpPr>
-          <p:cNvPr id="10" name="Rounded Rectangle 9"/>
+          <p:cNvPr id="12" name="Rounded Rectangle 11"/>
           <p:cNvSpPr/>
           <p:nvPr/>
         </p:nvSpPr>
@@ -5894,7 +6472,7 @@
       </p:sp>
       <p:sp>
         <p:nvSpPr>
-          <p:cNvPr id="11" name="Rounded Rectangle 10"/>
+          <p:cNvPr id="13" name="Rounded Rectangle 12"/>
           <p:cNvSpPr/>
           <p:nvPr/>
         </p:nvSpPr>
@@ -5960,7 +6538,7 @@
       </p:sp>
       <p:sp>
         <p:nvSpPr>
-          <p:cNvPr id="12" name="Rounded Rectangle 11"/>
+          <p:cNvPr id="14" name="Rounded Rectangle 13"/>
           <p:cNvSpPr/>
           <p:nvPr/>
         </p:nvSpPr>
@@ -6026,7 +6604,7 @@
       </p:sp>
       <p:sp>
         <p:nvSpPr>
-          <p:cNvPr id="13" name="TextBox 12"/>
+          <p:cNvPr id="15" name="TextBox 14"/>
           <p:cNvSpPr txBox="1"/>
           <p:nvPr/>
         </p:nvSpPr>
@@ -6176,7 +6754,115 @@
       </p:sp>
       <p:sp>
         <p:nvSpPr>
-          <p:cNvPr id="4" name="TextBox 3"/>
+          <p:cNvPr id="4" name="Rounded Rectangle 3"/>
+          <p:cNvSpPr/>
+          <p:nvPr/>
+        </p:nvSpPr>
+        <p:spPr>
+          <a:xfrm>
+            <a:off x="11018520" y="256032"/>
+            <a:ext cx="868680" cy="548640"/>
+          </a:xfrm>
+          <a:prstGeom prst="roundRect">
+            <a:avLst/>
+          </a:prstGeom>
+          <a:solidFill>
+            <a:srgbClr val="C27B2D"/>
+          </a:solidFill>
+          <a:ln>
+            <a:noFill/>
+          </a:ln>
+          <a:effectLst/>
+        </p:spPr>
+        <p:style>
+          <a:lnRef idx="1">
+            <a:schemeClr val="accent1"/>
+          </a:lnRef>
+          <a:fillRef idx="3">
+            <a:schemeClr val="accent1"/>
+          </a:fillRef>
+          <a:effectRef idx="2">
+            <a:schemeClr val="accent1"/>
+          </a:effectRef>
+          <a:fontRef idx="minor">
+            <a:schemeClr val="lt1"/>
+          </a:fontRef>
+        </p:style>
+        <p:txBody>
+          <a:bodyPr rtlCol="0" anchor="ctr"/>
+          <a:lstStyle/>
+          <a:p>
+            <a:pPr algn="ctr"/>
+            <a:r>
+              <a:rPr sz="1800" b="1">
+                <a:solidFill>
+                  <a:srgbClr val="FFFFFF"/>
+                </a:solidFill>
+                <a:latin typeface="Malgun Gothic"/>
+              </a:rPr>
+              <a:t>04</a:t>
+            </a:r>
+          </a:p>
+        </p:txBody>
+      </p:sp>
+      <p:sp>
+        <p:nvSpPr>
+          <p:cNvPr id="5" name="Rectangle 4"/>
+          <p:cNvSpPr/>
+          <p:nvPr/>
+        </p:nvSpPr>
+        <p:spPr>
+          <a:xfrm>
+            <a:off x="640080" y="1188720"/>
+            <a:ext cx="10881360" cy="566928"/>
+          </a:xfrm>
+          <a:prstGeom prst="rect">
+            <a:avLst/>
+          </a:prstGeom>
+          <a:solidFill>
+            <a:srgbClr val="E3E9F0"/>
+          </a:solidFill>
+          <a:ln w="9525">
+            <a:solidFill>
+              <a:srgbClr val="2E5E8C"/>
+            </a:solidFill>
+          </a:ln>
+          <a:effectLst/>
+        </p:spPr>
+        <p:style>
+          <a:lnRef idx="1">
+            <a:schemeClr val="accent1"/>
+          </a:lnRef>
+          <a:fillRef idx="3">
+            <a:schemeClr val="accent1"/>
+          </a:fillRef>
+          <a:effectRef idx="2">
+            <a:schemeClr val="accent1"/>
+          </a:effectRef>
+          <a:fontRef idx="minor">
+            <a:schemeClr val="lt1"/>
+          </a:fontRef>
+        </p:style>
+        <p:txBody>
+          <a:bodyPr rtlCol="0" anchor="ctr" wrap="square" lIns="182880"/>
+          <a:lstStyle/>
+          <a:p>
+            <a:pPr algn="ctr"/>
+            <a:r>
+              <a:rPr sz="1500" b="1">
+                <a:solidFill>
+                  <a:srgbClr val="1F3A5F"/>
+                </a:solidFill>
+                <a:latin typeface="Malgun Gothic"/>
+              </a:rPr>
+              <a:t>지역 문화·교육·미디어 조직에서 시작하기 쉬운 업무입니다.</a:t>
+            </a:r>
+          </a:p>
+        </p:txBody>
+      </p:sp>
+      <p:sp>
+        <p:nvSpPr>
+          <p:cNvPr id="6" name="TextBox 5"/>
           <p:cNvSpPr txBox="1"/>
           <p:nvPr/>
         </p:nvSpPr>
@@ -6210,7 +6896,7 @@
       </p:sp>
       <p:sp>
         <p:nvSpPr>
-          <p:cNvPr id="5" name="TextBox 4"/>
+          <p:cNvPr id="7" name="TextBox 6"/>
           <p:cNvSpPr txBox="1"/>
           <p:nvPr/>
         </p:nvSpPr>
@@ -6265,7 +6951,7 @@
       </p:sp>
       <p:sp>
         <p:nvSpPr>
-          <p:cNvPr id="6" name="Rounded Rectangle 5"/>
+          <p:cNvPr id="8" name="Rounded Rectangle 7"/>
           <p:cNvSpPr/>
           <p:nvPr/>
         </p:nvSpPr>
@@ -6320,7 +7006,7 @@
       </p:sp>
       <p:sp>
         <p:nvSpPr>
-          <p:cNvPr id="7" name="Rounded Rectangle 6"/>
+          <p:cNvPr id="9" name="Rounded Rectangle 8"/>
           <p:cNvSpPr/>
           <p:nvPr/>
         </p:nvSpPr>
@@ -6375,7 +7061,7 @@
       </p:sp>
       <p:sp>
         <p:nvSpPr>
-          <p:cNvPr id="8" name="Rounded Rectangle 7"/>
+          <p:cNvPr id="10" name="Rounded Rectangle 9"/>
           <p:cNvSpPr/>
           <p:nvPr/>
         </p:nvSpPr>
@@ -6430,7 +7116,7 @@
       </p:sp>
       <p:sp>
         <p:nvSpPr>
-          <p:cNvPr id="9" name="Rounded Rectangle 8"/>
+          <p:cNvPr id="11" name="Rounded Rectangle 10"/>
           <p:cNvSpPr/>
           <p:nvPr/>
         </p:nvSpPr>
@@ -6485,7 +7171,7 @@
       </p:sp>
       <p:sp>
         <p:nvSpPr>
-          <p:cNvPr id="10" name="Rounded Rectangle 9"/>
+          <p:cNvPr id="12" name="Rounded Rectangle 11"/>
           <p:cNvSpPr/>
           <p:nvPr/>
         </p:nvSpPr>
@@ -6540,7 +7226,7 @@
       </p:sp>
       <p:sp>
         <p:nvSpPr>
-          <p:cNvPr id="11" name="Rounded Rectangle 10"/>
+          <p:cNvPr id="13" name="Rounded Rectangle 12"/>
           <p:cNvSpPr/>
           <p:nvPr/>
         </p:nvSpPr>
@@ -6595,7 +7281,7 @@
       </p:sp>
       <p:sp>
         <p:nvSpPr>
-          <p:cNvPr id="12" name="TextBox 11"/>
+          <p:cNvPr id="14" name="TextBox 13"/>
           <p:cNvSpPr txBox="1"/>
           <p:nvPr/>
         </p:nvSpPr>
@@ -6745,7 +7431,115 @@
       </p:sp>
       <p:sp>
         <p:nvSpPr>
-          <p:cNvPr id="4" name="TextBox 3"/>
+          <p:cNvPr id="4" name="Rounded Rectangle 3"/>
+          <p:cNvSpPr/>
+          <p:nvPr/>
+        </p:nvSpPr>
+        <p:spPr>
+          <a:xfrm>
+            <a:off x="11018520" y="256032"/>
+            <a:ext cx="868680" cy="548640"/>
+          </a:xfrm>
+          <a:prstGeom prst="roundRect">
+            <a:avLst/>
+          </a:prstGeom>
+          <a:solidFill>
+            <a:srgbClr val="C27B2D"/>
+          </a:solidFill>
+          <a:ln>
+            <a:noFill/>
+          </a:ln>
+          <a:effectLst/>
+        </p:spPr>
+        <p:style>
+          <a:lnRef idx="1">
+            <a:schemeClr val="accent1"/>
+          </a:lnRef>
+          <a:fillRef idx="3">
+            <a:schemeClr val="accent1"/>
+          </a:fillRef>
+          <a:effectRef idx="2">
+            <a:schemeClr val="accent1"/>
+          </a:effectRef>
+          <a:fontRef idx="minor">
+            <a:schemeClr val="lt1"/>
+          </a:fontRef>
+        </p:style>
+        <p:txBody>
+          <a:bodyPr rtlCol="0" anchor="ctr"/>
+          <a:lstStyle/>
+          <a:p>
+            <a:pPr algn="ctr"/>
+            <a:r>
+              <a:rPr sz="1800" b="1">
+                <a:solidFill>
+                  <a:srgbClr val="FFFFFF"/>
+                </a:solidFill>
+                <a:latin typeface="Malgun Gothic"/>
+              </a:rPr>
+              <a:t>05</a:t>
+            </a:r>
+          </a:p>
+        </p:txBody>
+      </p:sp>
+      <p:sp>
+        <p:nvSpPr>
+          <p:cNvPr id="5" name="Rectangle 4"/>
+          <p:cNvSpPr/>
+          <p:nvPr/>
+        </p:nvSpPr>
+        <p:spPr>
+          <a:xfrm>
+            <a:off x="640080" y="1188720"/>
+            <a:ext cx="10881360" cy="566928"/>
+          </a:xfrm>
+          <a:prstGeom prst="rect">
+            <a:avLst/>
+          </a:prstGeom>
+          <a:solidFill>
+            <a:srgbClr val="E3E9F0"/>
+          </a:solidFill>
+          <a:ln w="9525">
+            <a:solidFill>
+              <a:srgbClr val="2E5E8C"/>
+            </a:solidFill>
+          </a:ln>
+          <a:effectLst/>
+        </p:spPr>
+        <p:style>
+          <a:lnRef idx="1">
+            <a:schemeClr val="accent1"/>
+          </a:lnRef>
+          <a:fillRef idx="3">
+            <a:schemeClr val="accent1"/>
+          </a:fillRef>
+          <a:effectRef idx="2">
+            <a:schemeClr val="accent1"/>
+          </a:effectRef>
+          <a:fontRef idx="minor">
+            <a:schemeClr val="lt1"/>
+          </a:fontRef>
+        </p:style>
+        <p:txBody>
+          <a:bodyPr rtlCol="0" anchor="ctr" wrap="square" lIns="182880"/>
+          <a:lstStyle/>
+          <a:p>
+            <a:pPr algn="ctr"/>
+            <a:r>
+              <a:rPr sz="1500" b="1">
+                <a:solidFill>
+                  <a:srgbClr val="1F3A5F"/>
+                </a:solidFill>
+                <a:latin typeface="Malgun Gothic"/>
+              </a:rPr>
+              <a:t>짧고 낮은 진입장벽으로 고객의 첫 결정을 만듭니다.</a:t>
+            </a:r>
+          </a:p>
+        </p:txBody>
+      </p:sp>
+      <p:sp>
+        <p:nvSpPr>
+          <p:cNvPr id="6" name="TextBox 5"/>
           <p:cNvSpPr txBox="1"/>
           <p:nvPr/>
         </p:nvSpPr>
@@ -6779,14 +7573,230 @@
       </p:sp>
       <p:sp>
         <p:nvSpPr>
-          <p:cNvPr id="5" name="TextBox 4"/>
+          <p:cNvPr id="7" name="Rounded Rectangle 6"/>
+          <p:cNvSpPr/>
+          <p:nvPr/>
+        </p:nvSpPr>
+        <p:spPr>
+          <a:xfrm>
+            <a:off x="640080" y="1920240"/>
+            <a:ext cx="2651760" cy="1188720"/>
+          </a:xfrm>
+          <a:prstGeom prst="roundRect">
+            <a:avLst/>
+          </a:prstGeom>
+          <a:solidFill>
+            <a:srgbClr val="2E5E8C"/>
+          </a:solidFill>
+          <a:ln>
+            <a:noFill/>
+          </a:ln>
+          <a:effectLst/>
+        </p:spPr>
+        <p:style>
+          <a:lnRef idx="1">
+            <a:schemeClr val="accent1"/>
+          </a:lnRef>
+          <a:fillRef idx="3">
+            <a:schemeClr val="accent1"/>
+          </a:fillRef>
+          <a:effectRef idx="2">
+            <a:schemeClr val="accent1"/>
+          </a:effectRef>
+          <a:fontRef idx="minor">
+            <a:schemeClr val="lt1"/>
+          </a:fontRef>
+        </p:style>
+        <p:txBody>
+          <a:bodyPr rtlCol="0" anchor="ctr"/>
+          <a:lstStyle/>
+          <a:p>
+            <a:pPr algn="ctr"/>
+            <a:r>
+              <a:rPr sz="1800" b="1">
+                <a:solidFill>
+                  <a:srgbClr val="FFFFFF"/>
+                </a:solidFill>
+                <a:latin typeface="Malgun Gothic"/>
+              </a:rPr>
+              <a:t>1~2일 워크숍</a:t>
+            </a:r>
+          </a:p>
+        </p:txBody>
+      </p:sp>
+      <p:sp>
+        <p:nvSpPr>
+          <p:cNvPr id="8" name="Rounded Rectangle 7"/>
+          <p:cNvSpPr/>
+          <p:nvPr/>
+        </p:nvSpPr>
+        <p:spPr>
+          <a:xfrm>
+            <a:off x="640080" y="3291840"/>
+            <a:ext cx="2651760" cy="1188720"/>
+          </a:xfrm>
+          <a:prstGeom prst="roundRect">
+            <a:avLst/>
+          </a:prstGeom>
+          <a:solidFill>
+            <a:srgbClr val="C27B2D"/>
+          </a:solidFill>
+          <a:ln>
+            <a:noFill/>
+          </a:ln>
+          <a:effectLst/>
+        </p:spPr>
+        <p:style>
+          <a:lnRef idx="1">
+            <a:schemeClr val="accent1"/>
+          </a:lnRef>
+          <a:fillRef idx="3">
+            <a:schemeClr val="accent1"/>
+          </a:fillRef>
+          <a:effectRef idx="2">
+            <a:schemeClr val="accent1"/>
+          </a:effectRef>
+          <a:fontRef idx="minor">
+            <a:schemeClr val="lt1"/>
+          </a:fontRef>
+        </p:style>
+        <p:txBody>
+          <a:bodyPr rtlCol="0" anchor="ctr"/>
+          <a:lstStyle/>
+          <a:p>
+            <a:pPr algn="ctr"/>
+            <a:r>
+              <a:rPr sz="1600" b="1">
+                <a:solidFill>
+                  <a:srgbClr val="FFFFFF"/>
+                </a:solidFill>
+                <a:latin typeface="Malgun Gothic"/>
+              </a:rPr>
+              <a:t>초기 제안 300만~500만원</a:t>
+            </a:r>
+          </a:p>
+        </p:txBody>
+      </p:sp>
+      <p:sp>
+        <p:nvSpPr>
+          <p:cNvPr id="9" name="Rectangle 8"/>
+          <p:cNvSpPr/>
+          <p:nvPr/>
+        </p:nvSpPr>
+        <p:spPr>
+          <a:xfrm>
+            <a:off x="3611880" y="1920240"/>
+            <a:ext cx="7909560" cy="2560320"/>
+          </a:xfrm>
+          <a:prstGeom prst="rect">
+            <a:avLst/>
+          </a:prstGeom>
+          <a:solidFill>
+            <a:srgbClr val="FFFFFF"/>
+          </a:solidFill>
+          <a:ln w="12700">
+            <a:solidFill>
+              <a:srgbClr val="2E5E8C"/>
+            </a:solidFill>
+          </a:ln>
+          <a:effectLst/>
+        </p:spPr>
+        <p:style>
+          <a:lnRef idx="1">
+            <a:schemeClr val="accent1"/>
+          </a:lnRef>
+          <a:fillRef idx="3">
+            <a:schemeClr val="accent1"/>
+          </a:fillRef>
+          <a:effectRef idx="2">
+            <a:schemeClr val="accent1"/>
+          </a:effectRef>
+          <a:fontRef idx="minor">
+            <a:schemeClr val="lt1"/>
+          </a:fontRef>
+        </p:style>
+        <p:txBody>
+          <a:bodyPr rtlCol="0" anchor="ctr" wrap="square" lIns="228600" tIns="182880"/>
+          <a:lstStyle/>
+          <a:p>
+            <a:pPr algn="ctr"/>
+            <a:r>
+              <a:rPr sz="1700" b="1">
+                <a:solidFill>
+                  <a:srgbClr val="1F3A5F"/>
+                </a:solidFill>
+                <a:latin typeface="Malgun Gothic"/>
+              </a:rPr>
+              <a:t>주요 산출물</a:t>
+            </a:r>
+          </a:p>
+          <a:p>
+            <a:r>
+              <a:rPr sz="1500">
+                <a:solidFill>
+                  <a:srgbClr val="555A60"/>
+                </a:solidFill>
+                <a:latin typeface="Malgun Gothic"/>
+              </a:rPr>
+              <a:t>•  현재 업무 흐름 진단</a:t>
+            </a:r>
+          </a:p>
+          <a:p>
+            <a:r>
+              <a:rPr sz="1500">
+                <a:solidFill>
+                  <a:srgbClr val="555A60"/>
+                </a:solidFill>
+                <a:latin typeface="Malgun Gothic"/>
+              </a:rPr>
+              <a:t>•  AI 적용 후보 업무 1~3개 선정</a:t>
+            </a:r>
+          </a:p>
+          <a:p>
+            <a:r>
+              <a:rPr sz="1500">
+                <a:solidFill>
+                  <a:srgbClr val="555A60"/>
+                </a:solidFill>
+                <a:latin typeface="Malgun Gothic"/>
+              </a:rPr>
+              <a:t>•  위험·금지 업무 분리</a:t>
+            </a:r>
+          </a:p>
+          <a:p>
+            <a:r>
+              <a:rPr sz="1500">
+                <a:solidFill>
+                  <a:srgbClr val="555A60"/>
+                </a:solidFill>
+                <a:latin typeface="Malgun Gothic"/>
+              </a:rPr>
+              <a:t>•  직무별 실습 결과</a:t>
+            </a:r>
+          </a:p>
+          <a:p>
+            <a:r>
+              <a:rPr sz="1500">
+                <a:solidFill>
+                  <a:srgbClr val="555A60"/>
+                </a:solidFill>
+                <a:latin typeface="Malgun Gothic"/>
+              </a:rPr>
+              <a:t>•  경영진 결과 보고</a:t>
+            </a:r>
+          </a:p>
+        </p:txBody>
+      </p:sp>
+      <p:sp>
+        <p:nvSpPr>
+          <p:cNvPr id="10" name="TextBox 9"/>
           <p:cNvSpPr txBox="1"/>
           <p:nvPr/>
         </p:nvSpPr>
         <p:spPr>
           <a:xfrm>
-            <a:off x="640080" y="1371600"/>
-            <a:ext cx="10881360" cy="4754880"/>
+            <a:off x="640080" y="4754880"/>
+            <a:ext cx="10881360" cy="1280160"/>
           </a:xfrm>
           <a:prstGeom prst="rect">
             <a:avLst/>
@@ -6805,76 +7815,12 @@
               </a:spcAft>
             </a:pPr>
             <a:r>
-              <a:rPr sz="2000" b="1">
-                <a:solidFill>
-                  <a:srgbClr val="1F3A5F"/>
-                </a:solidFill>
-                <a:latin typeface="Malgun Gothic"/>
-              </a:rPr>
-              <a:t>1~2일</a:t>
-            </a:r>
-          </a:p>
-          <a:p>
-            <a:pPr>
-              <a:spcAft>
-                <a:spcPts val="600"/>
-              </a:spcAft>
-            </a:pPr>
-            <a:r>
-              <a:rPr sz="1600" b="0">
+              <a:rPr sz="1400" b="0">
                 <a:solidFill>
                   <a:srgbClr val="555A60"/>
                 </a:solidFill>
                 <a:latin typeface="Malgun Gothic"/>
               </a:rPr>
-              <a:t>업무 현황 인터뷰, AI 적용 후보 선정, 위험업무 제외, 직무별 실습, 경영진 결과 보고</a:t>
-            </a:r>
-          </a:p>
-          <a:p>
-            <a:pPr>
-              <a:spcAft>
-                <a:spcPts val="600"/>
-              </a:spcAft>
-            </a:pPr>
-            <a:r>
-              <a:rPr sz="800" b="0">
-                <a:solidFill>
-                  <a:srgbClr val="555A60"/>
-                </a:solidFill>
-                <a:latin typeface="Malgun Gothic"/>
-              </a:rPr>
-              <a:t/>
-            </a:r>
-          </a:p>
-          <a:p>
-            <a:pPr>
-              <a:spcAft>
-                <a:spcPts val="600"/>
-              </a:spcAft>
-            </a:pPr>
-            <a:r>
-              <a:rPr sz="2200" b="1">
-                <a:solidFill>
-                  <a:srgbClr val="C27B2D"/>
-                </a:solidFill>
-                <a:latin typeface="Malgun Gothic"/>
-              </a:rPr>
-              <a:t>초기 제안 300만~500만원</a:t>
-            </a:r>
-          </a:p>
-          <a:p>
-            <a:pPr>
-              <a:spcAft>
-                <a:spcPts val="600"/>
-              </a:spcAft>
-            </a:pPr>
-            <a:r>
-              <a:rPr sz="1400" b="0">
-                <a:solidFill>
-                  <a:srgbClr val="555A60"/>
-                </a:solidFill>
-                <a:latin typeface="Malgun Gothic"/>
-              </a:rPr>
               <a:t>가격은 시장 검증 전 자사 가격 가설입니다. 범위와 인원·기간에 따라 최종 견적이 달라집니다.</a:t>
             </a:r>
           </a:p>
@@ -6882,7 +7828,7 @@
       </p:sp>
       <p:sp>
         <p:nvSpPr>
-          <p:cNvPr id="6" name="TextBox 5"/>
+          <p:cNvPr id="11" name="TextBox 10"/>
           <p:cNvSpPr txBox="1"/>
           <p:nvPr/>
         </p:nvSpPr>
@@ -7032,7 +7978,115 @@
       </p:sp>
       <p:sp>
         <p:nvSpPr>
-          <p:cNvPr id="4" name="TextBox 3"/>
+          <p:cNvPr id="4" name="Rounded Rectangle 3"/>
+          <p:cNvSpPr/>
+          <p:nvPr/>
+        </p:nvSpPr>
+        <p:spPr>
+          <a:xfrm>
+            <a:off x="11018520" y="256032"/>
+            <a:ext cx="868680" cy="548640"/>
+          </a:xfrm>
+          <a:prstGeom prst="roundRect">
+            <a:avLst/>
+          </a:prstGeom>
+          <a:solidFill>
+            <a:srgbClr val="C27B2D"/>
+          </a:solidFill>
+          <a:ln>
+            <a:noFill/>
+          </a:ln>
+          <a:effectLst/>
+        </p:spPr>
+        <p:style>
+          <a:lnRef idx="1">
+            <a:schemeClr val="accent1"/>
+          </a:lnRef>
+          <a:fillRef idx="3">
+            <a:schemeClr val="accent1"/>
+          </a:fillRef>
+          <a:effectRef idx="2">
+            <a:schemeClr val="accent1"/>
+          </a:effectRef>
+          <a:fontRef idx="minor">
+            <a:schemeClr val="lt1"/>
+          </a:fontRef>
+        </p:style>
+        <p:txBody>
+          <a:bodyPr rtlCol="0" anchor="ctr"/>
+          <a:lstStyle/>
+          <a:p>
+            <a:pPr algn="ctr"/>
+            <a:r>
+              <a:rPr sz="1800" b="1">
+                <a:solidFill>
+                  <a:srgbClr val="FFFFFF"/>
+                </a:solidFill>
+                <a:latin typeface="Malgun Gothic"/>
+              </a:rPr>
+              <a:t>06</a:t>
+            </a:r>
+          </a:p>
+        </p:txBody>
+      </p:sp>
+      <p:sp>
+        <p:nvSpPr>
+          <p:cNvPr id="5" name="Rectangle 4"/>
+          <p:cNvSpPr/>
+          <p:nvPr/>
+        </p:nvSpPr>
+        <p:spPr>
+          <a:xfrm>
+            <a:off x="640080" y="1188720"/>
+            <a:ext cx="10881360" cy="566928"/>
+          </a:xfrm>
+          <a:prstGeom prst="rect">
+            <a:avLst/>
+          </a:prstGeom>
+          <a:solidFill>
+            <a:srgbClr val="E3E9F0"/>
+          </a:solidFill>
+          <a:ln w="9525">
+            <a:solidFill>
+              <a:srgbClr val="2E5E8C"/>
+            </a:solidFill>
+          </a:ln>
+          <a:effectLst/>
+        </p:spPr>
+        <p:style>
+          <a:lnRef idx="1">
+            <a:schemeClr val="accent1"/>
+          </a:lnRef>
+          <a:fillRef idx="3">
+            <a:schemeClr val="accent1"/>
+          </a:fillRef>
+          <a:effectRef idx="2">
+            <a:schemeClr val="accent1"/>
+          </a:effectRef>
+          <a:fontRef idx="minor">
+            <a:schemeClr val="lt1"/>
+          </a:fontRef>
+        </p:style>
+        <p:txBody>
+          <a:bodyPr rtlCol="0" anchor="ctr" wrap="square" lIns="182880"/>
+          <a:lstStyle/>
+          <a:p>
+            <a:pPr algn="ctr"/>
+            <a:r>
+              <a:rPr sz="1500" b="1">
+                <a:solidFill>
+                  <a:srgbClr val="1F3A5F"/>
+                </a:solidFill>
+                <a:latin typeface="Malgun Gothic"/>
+              </a:rPr>
+              <a:t>작게 실행하고, 측정하고, 운영 기준을 남깁니다.</a:t>
+            </a:r>
+          </a:p>
+        </p:txBody>
+      </p:sp>
+      <p:sp>
+        <p:nvSpPr>
+          <p:cNvPr id="6" name="TextBox 5"/>
           <p:cNvSpPr txBox="1"/>
           <p:nvPr/>
         </p:nvSpPr>
@@ -7066,14 +8120,230 @@
       </p:sp>
       <p:sp>
         <p:nvSpPr>
-          <p:cNvPr id="5" name="TextBox 4"/>
+          <p:cNvPr id="7" name="Rounded Rectangle 6"/>
+          <p:cNvSpPr/>
+          <p:nvPr/>
+        </p:nvSpPr>
+        <p:spPr>
+          <a:xfrm>
+            <a:off x="640080" y="1920240"/>
+            <a:ext cx="2651760" cy="1188720"/>
+          </a:xfrm>
+          <a:prstGeom prst="roundRect">
+            <a:avLst/>
+          </a:prstGeom>
+          <a:solidFill>
+            <a:srgbClr val="2E5E8C"/>
+          </a:solidFill>
+          <a:ln>
+            <a:noFill/>
+          </a:ln>
+          <a:effectLst/>
+        </p:spPr>
+        <p:style>
+          <a:lnRef idx="1">
+            <a:schemeClr val="accent1"/>
+          </a:lnRef>
+          <a:fillRef idx="3">
+            <a:schemeClr val="accent1"/>
+          </a:fillRef>
+          <a:effectRef idx="2">
+            <a:schemeClr val="accent1"/>
+          </a:effectRef>
+          <a:fontRef idx="minor">
+            <a:schemeClr val="lt1"/>
+          </a:fontRef>
+        </p:style>
+        <p:txBody>
+          <a:bodyPr rtlCol="0" anchor="ctr"/>
+          <a:lstStyle/>
+          <a:p>
+            <a:pPr algn="ctr"/>
+            <a:r>
+              <a:rPr sz="1700" b="1">
+                <a:solidFill>
+                  <a:srgbClr val="FFFFFF"/>
+                </a:solidFill>
+                <a:latin typeface="Malgun Gothic"/>
+              </a:rPr>
+              <a:t>6주 · 1팀 · 1핵심 업무</a:t>
+            </a:r>
+          </a:p>
+        </p:txBody>
+      </p:sp>
+      <p:sp>
+        <p:nvSpPr>
+          <p:cNvPr id="8" name="Rounded Rectangle 7"/>
+          <p:cNvSpPr/>
+          <p:nvPr/>
+        </p:nvSpPr>
+        <p:spPr>
+          <a:xfrm>
+            <a:off x="640080" y="3291840"/>
+            <a:ext cx="2651760" cy="1188720"/>
+          </a:xfrm>
+          <a:prstGeom prst="roundRect">
+            <a:avLst/>
+          </a:prstGeom>
+          <a:solidFill>
+            <a:srgbClr val="C27B2D"/>
+          </a:solidFill>
+          <a:ln>
+            <a:noFill/>
+          </a:ln>
+          <a:effectLst/>
+        </p:spPr>
+        <p:style>
+          <a:lnRef idx="1">
+            <a:schemeClr val="accent1"/>
+          </a:lnRef>
+          <a:fillRef idx="3">
+            <a:schemeClr val="accent1"/>
+          </a:fillRef>
+          <a:effectRef idx="2">
+            <a:schemeClr val="accent1"/>
+          </a:effectRef>
+          <a:fontRef idx="minor">
+            <a:schemeClr val="lt1"/>
+          </a:fontRef>
+        </p:style>
+        <p:txBody>
+          <a:bodyPr rtlCol="0" anchor="ctr"/>
+          <a:lstStyle/>
+          <a:p>
+            <a:pPr algn="ctr"/>
+            <a:r>
+              <a:rPr sz="1800" b="1">
+                <a:solidFill>
+                  <a:srgbClr val="FFFFFF"/>
+                </a:solidFill>
+                <a:latin typeface="Malgun Gothic"/>
+              </a:rPr>
+              <a:t>1,000만~1,500만원</a:t>
+            </a:r>
+          </a:p>
+        </p:txBody>
+      </p:sp>
+      <p:sp>
+        <p:nvSpPr>
+          <p:cNvPr id="9" name="Rectangle 8"/>
+          <p:cNvSpPr/>
+          <p:nvPr/>
+        </p:nvSpPr>
+        <p:spPr>
+          <a:xfrm>
+            <a:off x="3611880" y="1920240"/>
+            <a:ext cx="7909560" cy="2560320"/>
+          </a:xfrm>
+          <a:prstGeom prst="rect">
+            <a:avLst/>
+          </a:prstGeom>
+          <a:solidFill>
+            <a:srgbClr val="FFFFFF"/>
+          </a:solidFill>
+          <a:ln w="12700">
+            <a:solidFill>
+              <a:srgbClr val="2E5E8C"/>
+            </a:solidFill>
+          </a:ln>
+          <a:effectLst/>
+        </p:spPr>
+        <p:style>
+          <a:lnRef idx="1">
+            <a:schemeClr val="accent1"/>
+          </a:lnRef>
+          <a:fillRef idx="3">
+            <a:schemeClr val="accent1"/>
+          </a:fillRef>
+          <a:effectRef idx="2">
+            <a:schemeClr val="accent1"/>
+          </a:effectRef>
+          <a:fontRef idx="minor">
+            <a:schemeClr val="lt1"/>
+          </a:fontRef>
+        </p:style>
+        <p:txBody>
+          <a:bodyPr rtlCol="0" anchor="ctr" wrap="square" lIns="228600" tIns="182880"/>
+          <a:lstStyle/>
+          <a:p>
+            <a:pPr algn="ctr"/>
+            <a:r>
+              <a:rPr sz="1700" b="1">
+                <a:solidFill>
+                  <a:srgbClr val="1F3A5F"/>
+                </a:solidFill>
+                <a:latin typeface="Malgun Gothic"/>
+              </a:rPr>
+              <a:t>파일럿 진행 흐름</a:t>
+            </a:r>
+          </a:p>
+          <a:p>
+            <a:r>
+              <a:rPr sz="1500">
+                <a:solidFill>
+                  <a:srgbClr val="555A60"/>
+                </a:solidFill>
+                <a:latin typeface="Malgun Gothic"/>
+              </a:rPr>
+              <a:t>•  기준선 측정</a:t>
+            </a:r>
+          </a:p>
+          <a:p>
+            <a:r>
+              <a:rPr sz="1500">
+                <a:solidFill>
+                  <a:srgbClr val="555A60"/>
+                </a:solidFill>
+                <a:latin typeface="Malgun Gothic"/>
+              </a:rPr>
+              <a:t>•  직무별 교육 · 실제 실습</a:t>
+            </a:r>
+          </a:p>
+          <a:p>
+            <a:r>
+              <a:rPr sz="1500">
+                <a:solidFill>
+                  <a:srgbClr val="555A60"/>
+                </a:solidFill>
+                <a:latin typeface="Malgun Gothic"/>
+              </a:rPr>
+              <a:t>•  워크플로 재설계 · 사람 검토 gate</a:t>
+            </a:r>
+          </a:p>
+          <a:p>
+            <a:r>
+              <a:rPr sz="1500">
+                <a:solidFill>
+                  <a:srgbClr val="555A60"/>
+                </a:solidFill>
+                <a:latin typeface="Malgun Gothic"/>
+              </a:rPr>
+              <a:t>•  제한 파일럿 실행</a:t>
+            </a:r>
+          </a:p>
+          <a:p>
+            <a:r>
+              <a:rPr sz="1500">
+                <a:solidFill>
+                  <a:srgbClr val="555A60"/>
+                </a:solidFill>
+                <a:latin typeface="Malgun Gothic"/>
+              </a:rPr>
+              <a:t>•  성과·위험 보고서 · 운영 플레이북</a:t>
+            </a:r>
+          </a:p>
+        </p:txBody>
+      </p:sp>
+      <p:sp>
+        <p:nvSpPr>
+          <p:cNvPr id="10" name="TextBox 9"/>
           <p:cNvSpPr txBox="1"/>
           <p:nvPr/>
         </p:nvSpPr>
         <p:spPr>
           <a:xfrm>
-            <a:off x="640080" y="1371600"/>
-            <a:ext cx="10881360" cy="4754880"/>
+            <a:off x="640080" y="4754880"/>
+            <a:ext cx="10881360" cy="1280160"/>
           </a:xfrm>
           <a:prstGeom prst="rect">
             <a:avLst/>
@@ -7092,76 +8362,12 @@
               </a:spcAft>
             </a:pPr>
             <a:r>
-              <a:rPr sz="2000" b="1">
-                <a:solidFill>
-                  <a:srgbClr val="1F3A5F"/>
-                </a:solidFill>
-                <a:latin typeface="Malgun Gothic"/>
-              </a:rPr>
-              <a:t>6주 · 1개 팀 · 1개 핵심 업무</a:t>
-            </a:r>
-          </a:p>
-          <a:p>
-            <a:pPr>
-              <a:spcAft>
-                <a:spcPts val="600"/>
-              </a:spcAft>
-            </a:pPr>
-            <a:r>
-              <a:rPr sz="1600" b="0">
+              <a:rPr sz="1400" b="0">
                 <a:solidFill>
                   <a:srgbClr val="555A60"/>
                 </a:solidFill>
                 <a:latin typeface="Malgun Gothic"/>
               </a:rPr>
-              <a:t>기준선 측정 → 직무별 교육 → 실제 실습 → 워크플로 재설계 → 제한 파일럿 → 성과·위험 보고 → 운영 플레이북</a:t>
-            </a:r>
-          </a:p>
-          <a:p>
-            <a:pPr>
-              <a:spcAft>
-                <a:spcPts val="600"/>
-              </a:spcAft>
-            </a:pPr>
-            <a:r>
-              <a:rPr sz="800" b="0">
-                <a:solidFill>
-                  <a:srgbClr val="555A60"/>
-                </a:solidFill>
-                <a:latin typeface="Malgun Gothic"/>
-              </a:rPr>
-              <a:t/>
-            </a:r>
-          </a:p>
-          <a:p>
-            <a:pPr>
-              <a:spcAft>
-                <a:spcPts val="600"/>
-              </a:spcAft>
-            </a:pPr>
-            <a:r>
-              <a:rPr sz="2200" b="1">
-                <a:solidFill>
-                  <a:srgbClr val="C27B2D"/>
-                </a:solidFill>
-                <a:latin typeface="Malgun Gothic"/>
-              </a:rPr>
-              <a:t>1,000만~1,500만원</a:t>
-            </a:r>
-          </a:p>
-          <a:p>
-            <a:pPr>
-              <a:spcAft>
-                <a:spcPts val="600"/>
-              </a:spcAft>
-            </a:pPr>
-            <a:r>
-              <a:rPr sz="1400" b="0">
-                <a:solidFill>
-                  <a:srgbClr val="555A60"/>
-                </a:solidFill>
-                <a:latin typeface="Malgun Gothic"/>
-              </a:rPr>
               <a:t>가격은 시장 검증 전 자사 가격 가설입니다. 범위와 인원·기간에 따라 최종 견적이 달라집니다.</a:t>
             </a:r>
           </a:p>
@@ -7169,7 +8375,7 @@
       </p:sp>
       <p:sp>
         <p:nvSpPr>
-          <p:cNvPr id="6" name="TextBox 5"/>
+          <p:cNvPr id="11" name="TextBox 10"/>
           <p:cNvSpPr txBox="1"/>
           <p:nvPr/>
         </p:nvSpPr>
@@ -7319,7 +8525,115 @@
       </p:sp>
       <p:sp>
         <p:nvSpPr>
-          <p:cNvPr id="4" name="TextBox 3"/>
+          <p:cNvPr id="4" name="Rounded Rectangle 3"/>
+          <p:cNvSpPr/>
+          <p:nvPr/>
+        </p:nvSpPr>
+        <p:spPr>
+          <a:xfrm>
+            <a:off x="11018520" y="256032"/>
+            <a:ext cx="868680" cy="548640"/>
+          </a:xfrm>
+          <a:prstGeom prst="roundRect">
+            <a:avLst/>
+          </a:prstGeom>
+          <a:solidFill>
+            <a:srgbClr val="C27B2D"/>
+          </a:solidFill>
+          <a:ln>
+            <a:noFill/>
+          </a:ln>
+          <a:effectLst/>
+        </p:spPr>
+        <p:style>
+          <a:lnRef idx="1">
+            <a:schemeClr val="accent1"/>
+          </a:lnRef>
+          <a:fillRef idx="3">
+            <a:schemeClr val="accent1"/>
+          </a:fillRef>
+          <a:effectRef idx="2">
+            <a:schemeClr val="accent1"/>
+          </a:effectRef>
+          <a:fontRef idx="minor">
+            <a:schemeClr val="lt1"/>
+          </a:fontRef>
+        </p:style>
+        <p:txBody>
+          <a:bodyPr rtlCol="0" anchor="ctr"/>
+          <a:lstStyle/>
+          <a:p>
+            <a:pPr algn="ctr"/>
+            <a:r>
+              <a:rPr sz="1800" b="1">
+                <a:solidFill>
+                  <a:srgbClr val="FFFFFF"/>
+                </a:solidFill>
+                <a:latin typeface="Malgun Gothic"/>
+              </a:rPr>
+              <a:t>07</a:t>
+            </a:r>
+          </a:p>
+        </p:txBody>
+      </p:sp>
+      <p:sp>
+        <p:nvSpPr>
+          <p:cNvPr id="5" name="Rectangle 4"/>
+          <p:cNvSpPr/>
+          <p:nvPr/>
+        </p:nvSpPr>
+        <p:spPr>
+          <a:xfrm>
+            <a:off x="640080" y="1188720"/>
+            <a:ext cx="10881360" cy="566928"/>
+          </a:xfrm>
+          <a:prstGeom prst="rect">
+            <a:avLst/>
+          </a:prstGeom>
+          <a:solidFill>
+            <a:srgbClr val="E3E9F0"/>
+          </a:solidFill>
+          <a:ln w="9525">
+            <a:solidFill>
+              <a:srgbClr val="2E5E8C"/>
+            </a:solidFill>
+          </a:ln>
+          <a:effectLst/>
+        </p:spPr>
+        <p:style>
+          <a:lnRef idx="1">
+            <a:schemeClr val="accent1"/>
+          </a:lnRef>
+          <a:fillRef idx="3">
+            <a:schemeClr val="accent1"/>
+          </a:fillRef>
+          <a:effectRef idx="2">
+            <a:schemeClr val="accent1"/>
+          </a:effectRef>
+          <a:fontRef idx="minor">
+            <a:schemeClr val="lt1"/>
+          </a:fontRef>
+        </p:style>
+        <p:txBody>
+          <a:bodyPr rtlCol="0" anchor="ctr" wrap="square" lIns="182880"/>
+          <a:lstStyle/>
+          <a:p>
+            <a:pPr algn="ctr"/>
+            <a:r>
+              <a:rPr sz="1500" b="1">
+                <a:solidFill>
+                  <a:srgbClr val="1F3A5F"/>
+                </a:solidFill>
+                <a:latin typeface="Malgun Gothic"/>
+              </a:rPr>
+              <a:t>계약 전 범위 확정부터 결과 보고까지 단계별로 진행합니다.</a:t>
+            </a:r>
+          </a:p>
+        </p:txBody>
+      </p:sp>
+      <p:sp>
+        <p:nvSpPr>
+          <p:cNvPr id="6" name="TextBox 5"/>
           <p:cNvSpPr txBox="1"/>
           <p:nvPr/>
         </p:nvSpPr>
@@ -7353,7 +8667,7 @@
       </p:sp>
       <p:sp>
         <p:nvSpPr>
-          <p:cNvPr id="5" name="Rounded Rectangle 4"/>
+          <p:cNvPr id="7" name="Rounded Rectangle 6"/>
           <p:cNvSpPr/>
           <p:nvPr/>
         </p:nvSpPr>
@@ -7406,7 +8720,7 @@
       </p:sp>
       <p:sp>
         <p:nvSpPr>
-          <p:cNvPr id="6" name="Rectangle 5"/>
+          <p:cNvPr id="8" name="Rectangle 7"/>
           <p:cNvSpPr/>
           <p:nvPr/>
         </p:nvSpPr>
@@ -7461,7 +8775,7 @@
       </p:sp>
       <p:sp>
         <p:nvSpPr>
-          <p:cNvPr id="7" name="Rounded Rectangle 6"/>
+          <p:cNvPr id="9" name="Rounded Rectangle 8"/>
           <p:cNvSpPr/>
           <p:nvPr/>
         </p:nvSpPr>
@@ -7514,7 +8828,7 @@
       </p:sp>
       <p:sp>
         <p:nvSpPr>
-          <p:cNvPr id="8" name="Rectangle 7"/>
+          <p:cNvPr id="10" name="Rectangle 9"/>
           <p:cNvSpPr/>
           <p:nvPr/>
         </p:nvSpPr>
@@ -7569,7 +8883,7 @@
       </p:sp>
       <p:sp>
         <p:nvSpPr>
-          <p:cNvPr id="9" name="Rounded Rectangle 8"/>
+          <p:cNvPr id="11" name="Rounded Rectangle 10"/>
           <p:cNvSpPr/>
           <p:nvPr/>
         </p:nvSpPr>
@@ -7622,7 +8936,7 @@
       </p:sp>
       <p:sp>
         <p:nvSpPr>
-          <p:cNvPr id="10" name="Rectangle 9"/>
+          <p:cNvPr id="12" name="Rectangle 11"/>
           <p:cNvSpPr/>
           <p:nvPr/>
         </p:nvSpPr>
@@ -7677,7 +8991,7 @@
       </p:sp>
       <p:sp>
         <p:nvSpPr>
-          <p:cNvPr id="11" name="Rounded Rectangle 10"/>
+          <p:cNvPr id="13" name="Rounded Rectangle 12"/>
           <p:cNvSpPr/>
           <p:nvPr/>
         </p:nvSpPr>
@@ -7730,7 +9044,7 @@
       </p:sp>
       <p:sp>
         <p:nvSpPr>
-          <p:cNvPr id="12" name="Rectangle 11"/>
+          <p:cNvPr id="14" name="Rectangle 13"/>
           <p:cNvSpPr/>
           <p:nvPr/>
         </p:nvSpPr>
@@ -7785,7 +9099,7 @@
       </p:sp>
       <p:sp>
         <p:nvSpPr>
-          <p:cNvPr id="13" name="Rounded Rectangle 12"/>
+          <p:cNvPr id="15" name="Rounded Rectangle 14"/>
           <p:cNvSpPr/>
           <p:nvPr/>
         </p:nvSpPr>
@@ -7838,7 +9152,7 @@
       </p:sp>
       <p:sp>
         <p:nvSpPr>
-          <p:cNvPr id="14" name="Rectangle 13"/>
+          <p:cNvPr id="16" name="Rectangle 15"/>
           <p:cNvSpPr/>
           <p:nvPr/>
         </p:nvSpPr>
@@ -7893,7 +9207,7 @@
       </p:sp>
       <p:sp>
         <p:nvSpPr>
-          <p:cNvPr id="15" name="Rounded Rectangle 14"/>
+          <p:cNvPr id="17" name="Rounded Rectangle 16"/>
           <p:cNvSpPr/>
           <p:nvPr/>
         </p:nvSpPr>
@@ -7946,7 +9260,7 @@
       </p:sp>
       <p:sp>
         <p:nvSpPr>
-          <p:cNvPr id="16" name="Rectangle 15"/>
+          <p:cNvPr id="18" name="Rectangle 17"/>
           <p:cNvSpPr/>
           <p:nvPr/>
         </p:nvSpPr>
@@ -8001,7 +9315,7 @@
       </p:sp>
       <p:sp>
         <p:nvSpPr>
-          <p:cNvPr id="17" name="Rounded Rectangle 16"/>
+          <p:cNvPr id="19" name="Rounded Rectangle 18"/>
           <p:cNvSpPr/>
           <p:nvPr/>
         </p:nvSpPr>
@@ -8054,7 +9368,7 @@
       </p:sp>
       <p:sp>
         <p:nvSpPr>
-          <p:cNvPr id="18" name="Rectangle 17"/>
+          <p:cNvPr id="20" name="Rectangle 19"/>
           <p:cNvSpPr/>
           <p:nvPr/>
         </p:nvSpPr>
@@ -8109,7 +9423,7 @@
       </p:sp>
       <p:sp>
         <p:nvSpPr>
-          <p:cNvPr id="19" name="TextBox 18"/>
+          <p:cNvPr id="21" name="TextBox 20"/>
           <p:cNvSpPr txBox="1"/>
           <p:nvPr/>
         </p:nvSpPr>
@@ -8259,7 +9573,115 @@
       </p:sp>
       <p:sp>
         <p:nvSpPr>
-          <p:cNvPr id="4" name="TextBox 3"/>
+          <p:cNvPr id="4" name="Rounded Rectangle 3"/>
+          <p:cNvSpPr/>
+          <p:nvPr/>
+        </p:nvSpPr>
+        <p:spPr>
+          <a:xfrm>
+            <a:off x="11018520" y="256032"/>
+            <a:ext cx="868680" cy="548640"/>
+          </a:xfrm>
+          <a:prstGeom prst="roundRect">
+            <a:avLst/>
+          </a:prstGeom>
+          <a:solidFill>
+            <a:srgbClr val="C27B2D"/>
+          </a:solidFill>
+          <a:ln>
+            <a:noFill/>
+          </a:ln>
+          <a:effectLst/>
+        </p:spPr>
+        <p:style>
+          <a:lnRef idx="1">
+            <a:schemeClr val="accent1"/>
+          </a:lnRef>
+          <a:fillRef idx="3">
+            <a:schemeClr val="accent1"/>
+          </a:fillRef>
+          <a:effectRef idx="2">
+            <a:schemeClr val="accent1"/>
+          </a:effectRef>
+          <a:fontRef idx="minor">
+            <a:schemeClr val="lt1"/>
+          </a:fontRef>
+        </p:style>
+        <p:txBody>
+          <a:bodyPr rtlCol="0" anchor="ctr"/>
+          <a:lstStyle/>
+          <a:p>
+            <a:pPr algn="ctr"/>
+            <a:r>
+              <a:rPr sz="1800" b="1">
+                <a:solidFill>
+                  <a:srgbClr val="FFFFFF"/>
+                </a:solidFill>
+                <a:latin typeface="Malgun Gothic"/>
+              </a:rPr>
+              <a:t>08</a:t>
+            </a:r>
+          </a:p>
+        </p:txBody>
+      </p:sp>
+      <p:sp>
+        <p:nvSpPr>
+          <p:cNvPr id="5" name="Rectangle 4"/>
+          <p:cNvSpPr/>
+          <p:nvPr/>
+        </p:nvSpPr>
+        <p:spPr>
+          <a:xfrm>
+            <a:off x="640080" y="1188720"/>
+            <a:ext cx="10881360" cy="566928"/>
+          </a:xfrm>
+          <a:prstGeom prst="rect">
+            <a:avLst/>
+          </a:prstGeom>
+          <a:solidFill>
+            <a:srgbClr val="E3E9F0"/>
+          </a:solidFill>
+          <a:ln w="9525">
+            <a:solidFill>
+              <a:srgbClr val="2E5E8C"/>
+            </a:solidFill>
+          </a:ln>
+          <a:effectLst/>
+        </p:spPr>
+        <p:style>
+          <a:lnRef idx="1">
+            <a:schemeClr val="accent1"/>
+          </a:lnRef>
+          <a:fillRef idx="3">
+            <a:schemeClr val="accent1"/>
+          </a:fillRef>
+          <a:effectRef idx="2">
+            <a:schemeClr val="accent1"/>
+          </a:effectRef>
+          <a:fontRef idx="minor">
+            <a:schemeClr val="lt1"/>
+          </a:fontRef>
+        </p:style>
+        <p:txBody>
+          <a:bodyPr rtlCol="0" anchor="ctr" wrap="square" lIns="182880"/>
+          <a:lstStyle/>
+          <a:p>
+            <a:pPr algn="ctr"/>
+            <a:r>
+              <a:rPr sz="1500" b="1">
+                <a:solidFill>
+                  <a:srgbClr val="1F3A5F"/>
+                </a:solidFill>
+                <a:latin typeface="Malgun Gothic"/>
+              </a:rPr>
+              <a:t>속도만 보지 않고 품질·채택·거버넌스를 함께 봅니다.</a:t>
+            </a:r>
+          </a:p>
+        </p:txBody>
+      </p:sp>
+      <p:sp>
+        <p:nvSpPr>
+          <p:cNvPr id="6" name="TextBox 5"/>
           <p:cNvSpPr txBox="1"/>
           <p:nvPr/>
         </p:nvSpPr>
@@ -8293,7 +9715,7 @@
       </p:sp>
       <p:sp>
         <p:nvSpPr>
-          <p:cNvPr id="5" name="TextBox 4"/>
+          <p:cNvPr id="7" name="TextBox 6"/>
           <p:cNvSpPr txBox="1"/>
           <p:nvPr/>
         </p:nvSpPr>
@@ -8364,7 +9786,7 @@
       </p:sp>
       <p:sp>
         <p:nvSpPr>
-          <p:cNvPr id="6" name="Rounded Rectangle 5"/>
+          <p:cNvPr id="8" name="Rounded Rectangle 7"/>
           <p:cNvSpPr/>
           <p:nvPr/>
         </p:nvSpPr>
@@ -8419,7 +9841,7 @@
       </p:sp>
       <p:sp>
         <p:nvSpPr>
-          <p:cNvPr id="7" name="Rounded Rectangle 6"/>
+          <p:cNvPr id="9" name="Rounded Rectangle 8"/>
           <p:cNvSpPr/>
           <p:nvPr/>
         </p:nvSpPr>
@@ -8474,7 +9896,7 @@
       </p:sp>
       <p:sp>
         <p:nvSpPr>
-          <p:cNvPr id="8" name="Rounded Rectangle 7"/>
+          <p:cNvPr id="10" name="Rounded Rectangle 9"/>
           <p:cNvSpPr/>
           <p:nvPr/>
         </p:nvSpPr>
@@ -8529,7 +9951,7 @@
       </p:sp>
       <p:sp>
         <p:nvSpPr>
-          <p:cNvPr id="9" name="Rounded Rectangle 8"/>
+          <p:cNvPr id="11" name="Rounded Rectangle 10"/>
           <p:cNvSpPr/>
           <p:nvPr/>
         </p:nvSpPr>
@@ -8584,7 +10006,7 @@
       </p:sp>
       <p:sp>
         <p:nvSpPr>
-          <p:cNvPr id="10" name="Rounded Rectangle 9"/>
+          <p:cNvPr id="12" name="Rounded Rectangle 11"/>
           <p:cNvSpPr/>
           <p:nvPr/>
         </p:nvSpPr>
@@ -8639,7 +10061,7 @@
       </p:sp>
       <p:sp>
         <p:nvSpPr>
-          <p:cNvPr id="11" name="Rounded Rectangle 10"/>
+          <p:cNvPr id="13" name="Rounded Rectangle 12"/>
           <p:cNvSpPr/>
           <p:nvPr/>
         </p:nvSpPr>
@@ -8694,7 +10116,7 @@
       </p:sp>
       <p:sp>
         <p:nvSpPr>
-          <p:cNvPr id="12" name="TextBox 11"/>
+          <p:cNvPr id="14" name="TextBox 13"/>
           <p:cNvSpPr txBox="1"/>
           <p:nvPr/>
         </p:nvSpPr>
@@ -8844,142 +10266,73 @@
       </p:sp>
       <p:sp>
         <p:nvSpPr>
-          <p:cNvPr id="4" name="TextBox 3"/>
-          <p:cNvSpPr txBox="1"/>
-          <p:nvPr/>
-        </p:nvSpPr>
-        <p:spPr>
-          <a:xfrm>
-            <a:off x="502920" y="6446520"/>
-            <a:ext cx="10698480" cy="320040"/>
+          <p:cNvPr id="4" name="Rounded Rectangle 3"/>
+          <p:cNvSpPr/>
+          <p:nvPr/>
+        </p:nvSpPr>
+        <p:spPr>
+          <a:xfrm>
+            <a:off x="11018520" y="256032"/>
+            <a:ext cx="868680" cy="548640"/>
+          </a:xfrm>
+          <a:prstGeom prst="roundRect">
+            <a:avLst/>
+          </a:prstGeom>
+          <a:solidFill>
+            <a:srgbClr val="C27B2D"/>
+          </a:solidFill>
+          <a:ln>
+            <a:noFill/>
+          </a:ln>
+          <a:effectLst/>
+        </p:spPr>
+        <p:style>
+          <a:lnRef idx="1">
+            <a:schemeClr val="accent1"/>
+          </a:lnRef>
+          <a:fillRef idx="3">
+            <a:schemeClr val="accent1"/>
+          </a:fillRef>
+          <a:effectRef idx="2">
+            <a:schemeClr val="accent1"/>
+          </a:effectRef>
+          <a:fontRef idx="minor">
+            <a:schemeClr val="lt1"/>
+          </a:fontRef>
+        </p:style>
+        <p:txBody>
+          <a:bodyPr rtlCol="0" anchor="ctr"/>
+          <a:lstStyle/>
+          <a:p>
+            <a:pPr algn="ctr"/>
+            <a:r>
+              <a:rPr sz="1800" b="1">
+                <a:solidFill>
+                  <a:srgbClr val="FFFFFF"/>
+                </a:solidFill>
+                <a:latin typeface="Malgun Gothic"/>
+              </a:rPr>
+              <a:t>09</a:t>
+            </a:r>
+          </a:p>
+        </p:txBody>
+      </p:sp>
+      <p:sp>
+        <p:nvSpPr>
+          <p:cNvPr id="5" name="Rectangle 4"/>
+          <p:cNvSpPr/>
+          <p:nvPr/>
+        </p:nvSpPr>
+        <p:spPr>
+          <a:xfrm>
+            <a:off x="640080" y="1188720"/>
+            <a:ext cx="10881360" cy="566928"/>
           </a:xfrm>
           <a:prstGeom prst="rect">
             <a:avLst/>
           </a:prstGeom>
-          <a:noFill/>
-        </p:spPr>
-        <p:txBody>
-          <a:bodyPr wrap="square">
-            <a:spAutoFit/>
-          </a:bodyPr>
-          <a:lstStyle/>
-          <a:p>
-            <a:r>
-              <a:rPr sz="1100">
-                <a:solidFill>
-                  <a:srgbClr val="555A60"/>
-                </a:solidFill>
-                <a:latin typeface="Malgun Gothic"/>
-              </a:rPr>
-              <a:t>DRAFT MASTER · LEGAL REVIEW REQUIRED</a:t>
-            </a:r>
-          </a:p>
-        </p:txBody>
-      </p:sp>
-      <p:sp>
-        <p:nvSpPr>
-          <p:cNvPr id="5" name="TextBox 4"/>
-          <p:cNvSpPr txBox="1"/>
-          <p:nvPr/>
-        </p:nvSpPr>
-        <p:spPr>
-          <a:xfrm>
-            <a:off x="640080" y="1371600"/>
-            <a:ext cx="10881360" cy="4754880"/>
-          </a:xfrm>
-          <a:prstGeom prst="rect">
-            <a:avLst/>
-          </a:prstGeom>
-          <a:noFill/>
-        </p:spPr>
-        <p:txBody>
-          <a:bodyPr wrap="square">
-            <a:spAutoFit/>
-          </a:bodyPr>
-          <a:lstStyle/>
-          <a:p/>
-          <a:p>
-            <a:pPr>
-              <a:spcAft>
-                <a:spcPts val="600"/>
-              </a:spcAft>
-            </a:pPr>
-            <a:r>
-              <a:rPr sz="600" b="0">
-                <a:solidFill>
-                  <a:srgbClr val="555A60"/>
-                </a:solidFill>
-                <a:latin typeface="Malgun Gothic"/>
-              </a:rPr>
-              <a:t/>
-            </a:r>
-          </a:p>
-          <a:p>
-            <a:pPr>
-              <a:spcAft>
-                <a:spcPts val="600"/>
-              </a:spcAft>
-            </a:pPr>
-            <a:r>
-              <a:rPr sz="1500" b="1">
-                <a:solidFill>
-                  <a:srgbClr val="C27B2D"/>
-                </a:solidFill>
-                <a:latin typeface="Malgun Gothic"/>
-              </a:rPr>
-              <a:t>시장 검증 전 자사 가격 가설</a:t>
-            </a:r>
-          </a:p>
-          <a:p>
-            <a:pPr>
-              <a:spcAft>
-                <a:spcPts val="600"/>
-              </a:spcAft>
-            </a:pPr>
-            <a:r>
-              <a:rPr sz="1500" b="1">
-                <a:solidFill>
-                  <a:srgbClr val="C27B2D"/>
-                </a:solidFill>
-                <a:latin typeface="Malgun Gothic"/>
-              </a:rPr>
-              <a:t>범위·인원·기간에 따라 최종 견적</a:t>
-            </a:r>
-          </a:p>
-          <a:p>
-            <a:pPr>
-              <a:spcAft>
-                <a:spcPts val="600"/>
-              </a:spcAft>
-            </a:pPr>
-            <a:r>
-              <a:rPr sz="1500" b="1">
-                <a:solidFill>
-                  <a:srgbClr val="C27B2D"/>
-                </a:solidFill>
-                <a:latin typeface="Malgun Gothic"/>
-              </a:rPr>
-              <a:t>VAT 조건은 최종 견적서에서 확정</a:t>
-            </a:r>
-          </a:p>
-        </p:txBody>
-      </p:sp>
-      <p:sp>
-        <p:nvSpPr>
-          <p:cNvPr id="6" name="Rectangle 5"/>
-          <p:cNvSpPr/>
-          <p:nvPr/>
-        </p:nvSpPr>
-        <p:spPr>
-          <a:xfrm>
-            <a:off x="640080" y="1737360"/>
-            <a:ext cx="10881360" cy="548640"/>
-          </a:xfrm>
-          <a:prstGeom prst="rect">
-            <a:avLst/>
-          </a:prstGeom>
           <a:solidFill>
-            <a:srgbClr val="FFFFFF"/>
+            <a:srgbClr val="E3E9F0"/>
           </a:solidFill>
           <a:ln w="9525">
             <a:solidFill>
@@ -9003,40 +10356,74 @@
           </a:fontRef>
         </p:style>
         <p:txBody>
-          <a:bodyPr rtlCol="0" anchor="ctr" lIns="182880"/>
-          <a:lstStyle/>
-          <a:p>
-            <a:pPr algn="ctr"/>
-            <a:r>
-              <a:rPr sz="1700">
+          <a:bodyPr rtlCol="0" anchor="ctr" wrap="square" lIns="182880"/>
+          <a:lstStyle/>
+          <a:p>
+            <a:pPr algn="ctr"/>
+            <a:r>
+              <a:rPr sz="1500" b="1">
                 <a:solidFill>
                   <a:srgbClr val="1F3A5F"/>
                 </a:solidFill>
                 <a:latin typeface="Malgun Gothic"/>
               </a:rPr>
-              <a:t>A 진단 워크숍           300만–800만원  (초기 제안 300만–500만원)</a:t>
-            </a:r>
-          </a:p>
-        </p:txBody>
-      </p:sp>
-      <p:sp>
-        <p:nvSpPr>
-          <p:cNvPr id="7" name="Rectangle 6"/>
+              <a:t>시장 검증 전 자사 가격 가설이며 범위 확인 후 최종 견적을 제시합니다.</a:t>
+            </a:r>
+          </a:p>
+        </p:txBody>
+      </p:sp>
+      <p:sp>
+        <p:nvSpPr>
+          <p:cNvPr id="6" name="TextBox 5"/>
+          <p:cNvSpPr txBox="1"/>
+          <p:nvPr/>
+        </p:nvSpPr>
+        <p:spPr>
+          <a:xfrm>
+            <a:off x="502920" y="6446520"/>
+            <a:ext cx="10698480" cy="320040"/>
+          </a:xfrm>
+          <a:prstGeom prst="rect">
+            <a:avLst/>
+          </a:prstGeom>
+          <a:noFill/>
+        </p:spPr>
+        <p:txBody>
+          <a:bodyPr wrap="square">
+            <a:spAutoFit/>
+          </a:bodyPr>
+          <a:lstStyle/>
+          <a:p>
+            <a:r>
+              <a:rPr sz="1100">
+                <a:solidFill>
+                  <a:srgbClr val="555A60"/>
+                </a:solidFill>
+                <a:latin typeface="Malgun Gothic"/>
+              </a:rPr>
+              <a:t>DRAFT MASTER · LEGAL REVIEW REQUIRED</a:t>
+            </a:r>
+          </a:p>
+        </p:txBody>
+      </p:sp>
+      <p:sp>
+        <p:nvSpPr>
+          <p:cNvPr id="7" name="Rounded Rectangle 6"/>
           <p:cNvSpPr/>
           <p:nvPr/>
         </p:nvSpPr>
         <p:spPr>
           <a:xfrm>
-            <a:off x="640080" y="2423160"/>
-            <a:ext cx="10881360" cy="548640"/>
-          </a:xfrm>
-          <a:prstGeom prst="rect">
+            <a:off x="640080" y="1737360"/>
+            <a:ext cx="2606040" cy="2377440"/>
+          </a:xfrm>
+          <a:prstGeom prst="roundRect">
             <a:avLst/>
           </a:prstGeom>
           <a:solidFill>
             <a:srgbClr val="FFFFFF"/>
           </a:solidFill>
-          <a:ln w="9525">
+          <a:ln w="15875">
             <a:solidFill>
               <a:srgbClr val="2E5E8C"/>
             </a:solidFill>
@@ -9058,40 +10445,76 @@
           </a:fontRef>
         </p:style>
         <p:txBody>
-          <a:bodyPr rtlCol="0" anchor="ctr" lIns="182880"/>
-          <a:lstStyle/>
-          <a:p>
-            <a:pPr algn="ctr"/>
-            <a:r>
-              <a:rPr sz="1700">
+          <a:bodyPr rtlCol="0" anchor="ctr" wrap="square"/>
+          <a:lstStyle/>
+          <a:p>
+            <a:pPr algn="ctr"/>
+            <a:r>
+              <a:rPr sz="1300" b="1">
+                <a:solidFill>
+                  <a:srgbClr val="2E5E8C"/>
+                </a:solidFill>
+                <a:latin typeface="Malgun Gothic"/>
+              </a:rPr>
+              <a:t>상품 A</a:t>
+            </a:r>
+          </a:p>
+          <a:p>
+            <a:pPr algn="ctr"/>
+            <a:r>
+              <a:rPr sz="1700" b="1">
                 <a:solidFill>
                   <a:srgbClr val="1F3A5F"/>
                 </a:solidFill>
                 <a:latin typeface="Malgun Gothic"/>
               </a:rPr>
-              <a:t>B 디자인 파트너 파일럿    1,000만–1,500만원</a:t>
-            </a:r>
-          </a:p>
-        </p:txBody>
-      </p:sp>
-      <p:sp>
-        <p:nvSpPr>
-          <p:cNvPr id="8" name="Rectangle 7"/>
+              <a:t>진단 워크숍</a:t>
+            </a:r>
+          </a:p>
+          <a:p>
+            <a:pPr algn="ctr"/>
+            <a:r>
+              <a:rPr sz="1700" b="1">
+                <a:solidFill>
+                  <a:srgbClr val="C27B2D"/>
+                </a:solidFill>
+                <a:latin typeface="Malgun Gothic"/>
+              </a:rPr>
+              <a:t>300만~800만원</a:t>
+            </a:r>
+          </a:p>
+          <a:p>
+            <a:pPr algn="ctr"/>
+            <a:r>
+              <a:rPr sz="1100">
+                <a:solidFill>
+                  <a:srgbClr val="555A60"/>
+                </a:solidFill>
+                <a:latin typeface="Malgun Gothic"/>
+              </a:rPr>
+              <a:t>초기 제안 300만~500만원</a:t>
+            </a:r>
+          </a:p>
+        </p:txBody>
+      </p:sp>
+      <p:sp>
+        <p:nvSpPr>
+          <p:cNvPr id="8" name="Rounded Rectangle 7"/>
           <p:cNvSpPr/>
           <p:nvPr/>
         </p:nvSpPr>
         <p:spPr>
           <a:xfrm>
-            <a:off x="640080" y="3108960"/>
-            <a:ext cx="10881360" cy="548640"/>
-          </a:xfrm>
-          <a:prstGeom prst="rect">
+            <a:off x="3474720" y="1737360"/>
+            <a:ext cx="2606040" cy="2377440"/>
+          </a:xfrm>
+          <a:prstGeom prst="roundRect">
             <a:avLst/>
           </a:prstGeom>
           <a:solidFill>
             <a:srgbClr val="FFFFFF"/>
           </a:solidFill>
-          <a:ln w="9525">
+          <a:ln w="15875">
             <a:solidFill>
               <a:srgbClr val="2E5E8C"/>
             </a:solidFill>
@@ -9113,40 +10536,76 @@
           </a:fontRef>
         </p:style>
         <p:txBody>
-          <a:bodyPr rtlCol="0" anchor="ctr" lIns="182880"/>
-          <a:lstStyle/>
-          <a:p>
-            <a:pPr algn="ctr"/>
-            <a:r>
-              <a:rPr sz="1700">
+          <a:bodyPr rtlCol="0" anchor="ctr" wrap="square"/>
+          <a:lstStyle/>
+          <a:p>
+            <a:pPr algn="ctr"/>
+            <a:r>
+              <a:rPr sz="1300" b="1">
+                <a:solidFill>
+                  <a:srgbClr val="2E5E8C"/>
+                </a:solidFill>
+                <a:latin typeface="Malgun Gothic"/>
+              </a:rPr>
+              <a:t>상품 B</a:t>
+            </a:r>
+          </a:p>
+          <a:p>
+            <a:pPr algn="ctr"/>
+            <a:r>
+              <a:rPr sz="1700" b="1">
                 <a:solidFill>
                   <a:srgbClr val="1F3A5F"/>
                 </a:solidFill>
                 <a:latin typeface="Malgun Gothic"/>
               </a:rPr>
-              <a:t>B 표준 6주 파일럿         1,500만–2,500만원</a:t>
-            </a:r>
-          </a:p>
-        </p:txBody>
-      </p:sp>
-      <p:sp>
-        <p:nvSpPr>
-          <p:cNvPr id="9" name="Rectangle 8"/>
+              <a:t>디자인 파트너</a:t>
+            </a:r>
+          </a:p>
+          <a:p>
+            <a:pPr algn="ctr"/>
+            <a:r>
+              <a:rPr sz="1700" b="1">
+                <a:solidFill>
+                  <a:srgbClr val="C27B2D"/>
+                </a:solidFill>
+                <a:latin typeface="Malgun Gothic"/>
+              </a:rPr>
+              <a:t>1,000만~1,500만원</a:t>
+            </a:r>
+          </a:p>
+          <a:p>
+            <a:pPr algn="ctr"/>
+            <a:r>
+              <a:rPr sz="1100">
+                <a:solidFill>
+                  <a:srgbClr val="555A60"/>
+                </a:solidFill>
+                <a:latin typeface="Malgun Gothic"/>
+              </a:rPr>
+              <a:t>6주 파일럿</a:t>
+            </a:r>
+          </a:p>
+        </p:txBody>
+      </p:sp>
+      <p:sp>
+        <p:nvSpPr>
+          <p:cNvPr id="9" name="Rounded Rectangle 8"/>
           <p:cNvSpPr/>
           <p:nvPr/>
         </p:nvSpPr>
         <p:spPr>
           <a:xfrm>
-            <a:off x="640080" y="3794760"/>
-            <a:ext cx="10881360" cy="548640"/>
-          </a:xfrm>
-          <a:prstGeom prst="rect">
+            <a:off x="6309360" y="1737360"/>
+            <a:ext cx="2606040" cy="2377440"/>
+          </a:xfrm>
+          <a:prstGeom prst="roundRect">
             <a:avLst/>
           </a:prstGeom>
           <a:solidFill>
             <a:srgbClr val="FFFFFF"/>
           </a:solidFill>
-          <a:ln w="9525">
+          <a:ln w="15875">
             <a:solidFill>
               <a:srgbClr val="2E5E8C"/>
             </a:solidFill>
@@ -9168,25 +10627,207 @@
           </a:fontRef>
         </p:style>
         <p:txBody>
-          <a:bodyPr rtlCol="0" anchor="ctr" lIns="182880"/>
-          <a:lstStyle/>
-          <a:p>
-            <a:pPr algn="ctr"/>
-            <a:r>
-              <a:rPr sz="1700">
+          <a:bodyPr rtlCol="0" anchor="ctr" wrap="square"/>
+          <a:lstStyle/>
+          <a:p>
+            <a:pPr algn="ctr"/>
+            <a:r>
+              <a:rPr sz="1300" b="1">
+                <a:solidFill>
+                  <a:srgbClr val="2E5E8C"/>
+                </a:solidFill>
+                <a:latin typeface="Malgun Gothic"/>
+              </a:rPr>
+              <a:t>상품 B</a:t>
+            </a:r>
+          </a:p>
+          <a:p>
+            <a:pPr algn="ctr"/>
+            <a:r>
+              <a:rPr sz="1700" b="1">
                 <a:solidFill>
                   <a:srgbClr val="1F3A5F"/>
                 </a:solidFill>
                 <a:latin typeface="Malgun Gothic"/>
               </a:rPr>
-              <a:t>C 조직 운영 자문          월 300만–600만원</a:t>
-            </a:r>
-          </a:p>
-        </p:txBody>
-      </p:sp>
-      <p:sp>
-        <p:nvSpPr>
-          <p:cNvPr id="10" name="TextBox 9"/>
+              <a:t>표준 파일럿</a:t>
+            </a:r>
+          </a:p>
+          <a:p>
+            <a:pPr algn="ctr"/>
+            <a:r>
+              <a:rPr sz="1700" b="1">
+                <a:solidFill>
+                  <a:srgbClr val="C27B2D"/>
+                </a:solidFill>
+                <a:latin typeface="Malgun Gothic"/>
+              </a:rPr>
+              <a:t>1,500만~2,500만원</a:t>
+            </a:r>
+          </a:p>
+          <a:p>
+            <a:pPr algn="ctr"/>
+            <a:r>
+              <a:rPr sz="1100">
+                <a:solidFill>
+                  <a:srgbClr val="555A60"/>
+                </a:solidFill>
+                <a:latin typeface="Malgun Gothic"/>
+              </a:rPr>
+              <a:t>6주 파일럿</a:t>
+            </a:r>
+          </a:p>
+        </p:txBody>
+      </p:sp>
+      <p:sp>
+        <p:nvSpPr>
+          <p:cNvPr id="10" name="Rounded Rectangle 9"/>
+          <p:cNvSpPr/>
+          <p:nvPr/>
+        </p:nvSpPr>
+        <p:spPr>
+          <a:xfrm>
+            <a:off x="9144000" y="1737360"/>
+            <a:ext cx="2606040" cy="2377440"/>
+          </a:xfrm>
+          <a:prstGeom prst="roundRect">
+            <a:avLst/>
+          </a:prstGeom>
+          <a:solidFill>
+            <a:srgbClr val="FFFFFF"/>
+          </a:solidFill>
+          <a:ln w="15875">
+            <a:solidFill>
+              <a:srgbClr val="2E5E8C"/>
+            </a:solidFill>
+          </a:ln>
+          <a:effectLst/>
+        </p:spPr>
+        <p:style>
+          <a:lnRef idx="1">
+            <a:schemeClr val="accent1"/>
+          </a:lnRef>
+          <a:fillRef idx="3">
+            <a:schemeClr val="accent1"/>
+          </a:fillRef>
+          <a:effectRef idx="2">
+            <a:schemeClr val="accent1"/>
+          </a:effectRef>
+          <a:fontRef idx="minor">
+            <a:schemeClr val="lt1"/>
+          </a:fontRef>
+        </p:style>
+        <p:txBody>
+          <a:bodyPr rtlCol="0" anchor="ctr" wrap="square"/>
+          <a:lstStyle/>
+          <a:p>
+            <a:pPr algn="ctr"/>
+            <a:r>
+              <a:rPr sz="1300" b="1">
+                <a:solidFill>
+                  <a:srgbClr val="2E5E8C"/>
+                </a:solidFill>
+                <a:latin typeface="Malgun Gothic"/>
+              </a:rPr>
+              <a:t>상품 C</a:t>
+            </a:r>
+          </a:p>
+          <a:p>
+            <a:pPr algn="ctr"/>
+            <a:r>
+              <a:rPr sz="1700" b="1">
+                <a:solidFill>
+                  <a:srgbClr val="1F3A5F"/>
+                </a:solidFill>
+                <a:latin typeface="Malgun Gothic"/>
+              </a:rPr>
+              <a:t>운영 자문</a:t>
+            </a:r>
+          </a:p>
+          <a:p>
+            <a:pPr algn="ctr"/>
+            <a:r>
+              <a:rPr sz="1700" b="1">
+                <a:solidFill>
+                  <a:srgbClr val="C27B2D"/>
+                </a:solidFill>
+                <a:latin typeface="Malgun Gothic"/>
+              </a:rPr>
+              <a:t>월 300만~600만원</a:t>
+            </a:r>
+          </a:p>
+          <a:p>
+            <a:pPr algn="ctr"/>
+            <a:r>
+              <a:rPr sz="1100">
+                <a:solidFill>
+                  <a:srgbClr val="555A60"/>
+                </a:solidFill>
+                <a:latin typeface="Malgun Gothic"/>
+              </a:rPr>
+              <a:t>월 단위</a:t>
+            </a:r>
+          </a:p>
+        </p:txBody>
+      </p:sp>
+      <p:sp>
+        <p:nvSpPr>
+          <p:cNvPr id="11" name="TextBox 10"/>
+          <p:cNvSpPr txBox="1"/>
+          <p:nvPr/>
+        </p:nvSpPr>
+        <p:spPr>
+          <a:xfrm>
+            <a:off x="640080" y="4480560"/>
+            <a:ext cx="10881360" cy="1463040"/>
+          </a:xfrm>
+          <a:prstGeom prst="rect">
+            <a:avLst/>
+          </a:prstGeom>
+          <a:noFill/>
+        </p:spPr>
+        <p:txBody>
+          <a:bodyPr wrap="square">
+            <a:spAutoFit/>
+          </a:bodyPr>
+          <a:lstStyle/>
+          <a:p>
+            <a:pPr>
+              <a:spcAft>
+                <a:spcPts val="600"/>
+              </a:spcAft>
+            </a:pPr>
+            <a:r>
+              <a:rPr sz="1500" b="1">
+                <a:solidFill>
+                  <a:srgbClr val="C27B2D"/>
+                </a:solidFill>
+                <a:latin typeface="Malgun Gothic"/>
+              </a:rPr>
+              <a:t>시장 검증 전 자사 가격 가설</a:t>
+            </a:r>
+          </a:p>
+          <a:p>
+            <a:pPr>
+              <a:spcAft>
+                <a:spcPts val="600"/>
+              </a:spcAft>
+            </a:pPr>
+            <a:r>
+              <a:rPr sz="1500" b="1">
+                <a:solidFill>
+                  <a:srgbClr val="C27B2D"/>
+                </a:solidFill>
+                <a:latin typeface="Malgun Gothic"/>
+              </a:rPr>
+              <a:t>범위·인원·기간에 따라 최종 견적 · VAT 조건은 최종 견적서에서 확정</a:t>
+            </a:r>
+          </a:p>
+        </p:txBody>
+      </p:sp>
+      <p:sp>
+        <p:nvSpPr>
+          <p:cNvPr id="12" name="TextBox 11"/>
           <p:cNvSpPr txBox="1"/>
           <p:nvPr/>
         </p:nvSpPr>

</xml_diff>

<commit_message>
docs(ai-media-education-dx): apply Padiem provider identity
Apply final provider identity 파디엠 (PADIEM) to the Business 35 customer package.

- Proposal: cover shows '제공: 파디엠'; all footers '파디엠 · DRAFT'; last page adds '제공 및 계약 주체: 파디엠' + pricing/legal-review closing
- One-page: '제공: 파디엠' in header, footer '파디엠 · DRAFT'
- Questionnaire: repeating page header '파디엠 · AI 업무전환 진단 질문지' + [N/3]
- Quote workbook: supplier/contracting/issuer = 파디엠; business details marked '발송 전 공식 사업자 정보 입력 필요' (no invented numbers)
- Meeting script / emails: Padiem self-intro, sender '파디엠 · AI 업무전환 프로그램'
- Internal docs (README/CHECKLIST/SOURCE_MAPPING/VISUAL_QA/REFERENCE_COMPARISON): FINAL_IDENTITY_DECIDED · PROVIDER 파디엠 · CONTRACTING_ENTITY 파디엠 · BUSINESS_DETAILS_VERIFICATION_PENDING
- Pricing/product scope unchanged (A/B1/B2/C)
- AI Revenue Lab not shown as contracting entity

Validation: ALL CHECKS PASSED; git diff --check clean; PDF 10/1/3; renders 14; XLSX 9 sheets.

Refs #359.
</commit_message>
<xml_diff>
--- a/docs/commercial/business-35-ai-media-education-dx/customer-package/Business35_Master_Proposal_10p.pptx
+++ b/docs/commercial/business-35-ai-media-education-dx/customer-package/Business35_Master_Proposal_10p.pptx
@@ -511,7 +511,7 @@
           <a:lstStyle/>
           <a:p>
             <a:r>
-              <a:t>핵심 말할 내용: 표지에서 제품명·핵심 제안 한 문장·대상 고객군·대표 진입 상품·DRAFT 상태만 보여준다.</a:t>
+              <a:t>핵심 말할 내용: 표지에서 제품명·핵심 제안 한 문장·제공자(파디엠)·대상 고객군·대표 진입 상품·DRAFT 상태만 보여준다.</a:t>
             </a:r>
           </a:p>
           <a:p/>
@@ -4501,7 +4501,7 @@
                 </a:solidFill>
                 <a:latin typeface="Malgun Gothic"/>
               </a:rPr>
-              <a:t>DRAFT · 제공자 정보 및 법률 검토 필요</a:t>
+              <a:t>파디엠 · DRAFT</a:t>
             </a:r>
           </a:p>
         </p:txBody>
@@ -4541,6 +4541,25 @@
                 <a:latin typeface="Malgun Gothic"/>
               </a:rPr>
               <a:t>지역 문화·교육·미디어 조직을 위한 진단·실습·워크플로 재설계·파일럿 프로그램</a:t>
+            </a:r>
+          </a:p>
+          <a:p>
+            <a:pPr>
+              <a:spcBef>
+                <a:spcPts val="1200"/>
+              </a:spcBef>
+              <a:spcAft>
+                <a:spcPts val="800"/>
+              </a:spcAft>
+            </a:pPr>
+            <a:r>
+              <a:rPr sz="1400" b="1">
+                <a:solidFill>
+                  <a:srgbClr val="2E5E8C"/>
+                </a:solidFill>
+                <a:latin typeface="Malgun Gothic"/>
+              </a:rPr>
+              <a:t>제공: 파디엠</a:t>
             </a:r>
           </a:p>
           <a:p>
@@ -4889,7 +4908,7 @@
                 </a:solidFill>
                 <a:latin typeface="Malgun Gothic"/>
               </a:rPr>
-              <a:t>제공자 정보 최종 확정 필요  ·  제안 제공자 정보는 발송 전 최종 확정</a:t>
+              <a:t>파디엠 · DRAFT</a:t>
             </a:r>
           </a:p>
         </p:txBody>
@@ -5215,7 +5234,7 @@
         <p:spPr>
           <a:xfrm>
             <a:off x="640080" y="4480560"/>
-            <a:ext cx="10881360" cy="1463040"/>
+            <a:ext cx="10881360" cy="1645920"/>
           </a:xfrm>
           <a:prstGeom prst="rect">
             <a:avLst/>
@@ -5260,6 +5279,63 @@
                 <a:latin typeface="Malgun Gothic"/>
               </a:rPr>
               <a:t>조직별 사용정책·검토체계, 개인정보·저작권·조달, 전문 법률·계약 검토가 필요합니다.</a:t>
+            </a:r>
+          </a:p>
+          <a:p>
+            <a:pPr>
+              <a:spcBef>
+                <a:spcPts val="1200"/>
+              </a:spcBef>
+              <a:spcAft>
+                <a:spcPts val="800"/>
+              </a:spcAft>
+            </a:pPr>
+            <a:r>
+              <a:rPr sz="1400" b="1">
+                <a:solidFill>
+                  <a:srgbClr val="1F3A5F"/>
+                </a:solidFill>
+                <a:latin typeface="Malgun Gothic"/>
+              </a:rPr>
+              <a:t>제공 및 계약 주체: 파디엠</a:t>
+            </a:r>
+          </a:p>
+          <a:p>
+            <a:pPr>
+              <a:spcBef>
+                <a:spcPts val="600"/>
+              </a:spcBef>
+              <a:spcAft>
+                <a:spcPts val="800"/>
+              </a:spcAft>
+            </a:pPr>
+            <a:r>
+              <a:rPr sz="1200" b="0">
+                <a:solidFill>
+                  <a:srgbClr val="555A60"/>
+                </a:solidFill>
+                <a:latin typeface="Malgun Gothic"/>
+              </a:rPr>
+              <a:t>가격은 시장 검증 전 가설이며 범위·인원·기간에 따라 달라질 수 있습니다.</a:t>
+            </a:r>
+          </a:p>
+          <a:p>
+            <a:pPr>
+              <a:spcBef>
+                <a:spcPts val="400"/>
+              </a:spcBef>
+              <a:spcAft>
+                <a:spcPts val="800"/>
+              </a:spcAft>
+            </a:pPr>
+            <a:r>
+              <a:rPr sz="1200" b="0">
+                <a:solidFill>
+                  <a:srgbClr val="555A60"/>
+                </a:solidFill>
+                <a:latin typeface="Malgun Gothic"/>
+              </a:rPr>
+              <a:t>전문 법률·계약 검토 후 최종 확정됩니다.</a:t>
             </a:r>
           </a:p>
         </p:txBody>
@@ -5551,7 +5627,7 @@
                 </a:solidFill>
                 <a:latin typeface="Malgun Gothic"/>
               </a:rPr>
-              <a:t>DRAFT</a:t>
+              <a:t>파디엠 · DRAFT</a:t>
             </a:r>
           </a:p>
         </p:txBody>
@@ -6140,7 +6216,7 @@
                 </a:solidFill>
                 <a:latin typeface="Malgun Gothic"/>
               </a:rPr>
-              <a:t>DRAFT</a:t>
+              <a:t>파디엠 · DRAFT</a:t>
             </a:r>
           </a:p>
         </p:txBody>
@@ -6661,7 +6737,7 @@
                 </a:solidFill>
                 <a:latin typeface="Malgun Gothic"/>
               </a:rPr>
-              <a:t>DRAFT</a:t>
+              <a:t>파디엠 · DRAFT</a:t>
             </a:r>
           </a:p>
         </p:txBody>
@@ -7718,7 +7794,7 @@
                 </a:solidFill>
                 <a:latin typeface="Malgun Gothic"/>
               </a:rPr>
-              <a:t>DRAFT</a:t>
+              <a:t>파디엠 · DRAFT</a:t>
             </a:r>
           </a:p>
         </p:txBody>
@@ -8379,7 +8455,7 @@
                 </a:solidFill>
                 <a:latin typeface="Malgun Gothic"/>
               </a:rPr>
-              <a:t>DRAFT</a:t>
+              <a:t>파디엠 · DRAFT</a:t>
             </a:r>
           </a:p>
         </p:txBody>
@@ -8938,7 +9014,7 @@
                 </a:solidFill>
                 <a:latin typeface="Malgun Gothic"/>
               </a:rPr>
-              <a:t>DRAFT</a:t>
+              <a:t>파디엠 · DRAFT</a:t>
             </a:r>
           </a:p>
         </p:txBody>
@@ -10216,7 +10292,7 @@
                 </a:solidFill>
                 <a:latin typeface="Malgun Gothic"/>
               </a:rPr>
-              <a:t>DRAFT</a:t>
+              <a:t>파디엠 · DRAFT</a:t>
             </a:r>
           </a:p>
         </p:txBody>
@@ -10935,7 +11011,7 @@
                 </a:solidFill>
                 <a:latin typeface="Malgun Gothic"/>
               </a:rPr>
-              <a:t>DRAFT</a:t>
+              <a:t>파디엠 · DRAFT</a:t>
             </a:r>
           </a:p>
         </p:txBody>

</xml_diff>